<commit_message>
docs(eval): add live Cloud Monitoring metrics dashboard (model-metric visibility)
Every eval score is a first-class Cloud Monitoring metric (custom.googleapis.com/
agent_eval/*, online_evaluator/scores). Add a real capture of the GEAP Agent
Performance & Quality dashboard showing quality drift, embedded in eval_operations,
the demo walkthrough, and slide 4 of both the HTML and PPTX decks; note Metrics
Explorer + publish_metrics.py. Drop the unused empty metrics-explorer builder shot.
</commit_message>
<xml_diff>
--- a/docs/eval_slides.pptx
+++ b/docs/eval_slides.pptx
@@ -5164,6 +5164,39 @@
                 </a:solidFill>
                 <a:latin typeface="Arial"/>
               </a:rPr>
+              <a:t>Metrics Explorer &amp; dashboards</a:t>
+            </a:r>
+            <a:r>
+              <a:rPr sz="1250" b="0">
+                <a:solidFill>
+                  <a:srgbClr val="3C4043"/>
+                </a:solidFill>
+                <a:latin typeface="Arial"/>
+              </a:rPr>
+              <a:t> — every score is a first-class Cloud Monitoring metric (agent_eval/*, online_evaluator/scores) you can chart, compare &amp; share.</a:t>
+            </a:r>
+          </a:p>
+          <a:p>
+            <a:pPr>
+              <a:spcAft>
+                <a:spcPts val="800"/>
+              </a:spcAft>
+            </a:pPr>
+            <a:r>
+              <a:rPr sz="1000">
+                <a:solidFill>
+                  <a:srgbClr val="1A73E8"/>
+                </a:solidFill>
+              </a:rPr>
+              <a:t>●  </a:t>
+            </a:r>
+            <a:r>
+              <a:rPr sz="1250" b="1">
+                <a:solidFill>
+                  <a:srgbClr val="202124"/>
+                </a:solidFill>
+                <a:latin typeface="Arial"/>
+              </a:rPr>
               <a:t>Quality-drift alerts</a:t>
             </a:r>
             <a:r>
@@ -5173,7 +5206,7 @@
                 </a:solidFill>
                 <a:latin typeface="Arial"/>
               </a:rPr>
-              <a:t> — three paths: per-monitor policy, dashboard “Recommended Alerts”, or programmatic gcloud / monitoring_v3 on online_evaluator/scores.</a:t>
+              <a:t> — per-monitor policy, dashboard “Recommended Alerts”, or programmatic gcloud / monitoring_v3.</a:t>
             </a:r>
           </a:p>
         </p:txBody>
@@ -5252,7 +5285,7 @@
                 <a:latin typeface="Consolas"/>
                 <a:hlinkClick r:id="rId4"/>
               </a:rPr>
-              <a:t>&lt;/&gt; quality_alerts.py    </a:t>
+              <a:t>&lt;/&gt; publish_metrics.py    </a:t>
             </a:r>
             <a:r>
               <a:rPr sz="1100">
@@ -5262,7 +5295,7 @@
                 <a:latin typeface="Consolas"/>
                 <a:hlinkClick r:id="rId5"/>
               </a:rPr>
-              <a:t>&lt;/&gt; policies/quality_drift_policy.yaml    </a:t>
+              <a:t>&lt;/&gt; quality_alerts.py    </a:t>
             </a:r>
           </a:p>
         </p:txBody>
@@ -5298,7 +5331,7 @@
       </p:pic>
       <p:pic>
         <p:nvPicPr>
-          <p:cNvPr id="12" name="Picture 11" descr="eval_console_monitoring_alerts.png"/>
+          <p:cNvPr id="12" name="Picture 11" descr="eval_console_metrics_dashboard.png"/>
           <p:cNvPicPr>
             <a:picLocks noChangeAspect="1"/>
           </p:cNvPicPr>

</xml_diff>

<commit_message>
docs+eval: remove loss/failure-cluster feature; republish cluster-free slides
Auto-loss analysis is blocked upstream (#6785) and required a monkey-patch we don't
want, so remove it entirely:
- delete src/eval/failure_clusters.py and src/eval/loss_taxonomy.py
- drop the analyze/cluster step from the demo (steps.py, full_eval_demo.py, notebook)
- strip cluster/taxonomy mentions from eval_operations, evaluation_demo, workshop_guide,
  faq, project_structure, slides.html, and the agents-cli demo
- view-results coverage now points at the notebook (result.show())
Republish the eval slide deck (HTML + PPTX) cluster-free; tests updated (81 pass).
</commit_message>
<xml_diff>
--- a/docs/eval_slides.pptx
+++ b/docs/eval_slides.pptx
@@ -10,6 +10,8 @@
     <p:sldId id="258" r:id="rId9"/>
     <p:sldId id="259" r:id="rId10"/>
     <p:sldId id="260" r:id="rId11"/>
+    <p:sldId id="261" r:id="rId12"/>
+    <p:sldId id="262" r:id="rId13"/>
   </p:sldIdLst>
   <p:sldSz cx="12191695" cy="6858000" type="screen4x3"/>
   <p:notesSz cx="6858000" cy="9144000"/>
@@ -3194,8 +3196,8 @@
         </p:nvSpPr>
         <p:spPr>
           <a:xfrm>
-            <a:off x="10698480" y="146304"/>
-            <a:ext cx="1005840" cy="365760"/>
+            <a:off x="10607040" y="146304"/>
+            <a:ext cx="1097280" cy="365760"/>
           </a:xfrm>
           <a:prstGeom prst="rect">
             <a:avLst/>
@@ -3215,7 +3217,7 @@
                   <a:srgbClr val="1967D2"/>
                 </a:solidFill>
               </a:rPr>
-              <a:t>1 / 5</a:t>
+              <a:t>1 / 7</a:t>
             </a:r>
           </a:p>
         </p:txBody>
@@ -3228,8 +3230,8 @@
         </p:nvSpPr>
         <p:spPr>
           <a:xfrm>
-            <a:off x="548640" y="960120"/>
-            <a:ext cx="3017520" cy="310896"/>
+            <a:off x="4093311" y="1234440"/>
+            <a:ext cx="4005072" cy="329184"/>
           </a:xfrm>
           <a:prstGeom prst="roundRect">
             <a:avLst/>
@@ -3266,7 +3268,7 @@
                   <a:srgbClr val="1967D2"/>
                 </a:solidFill>
               </a:rPr>
-              <a:t>THE QUALITY FLYWHEEL</a:t>
+              <a:t>GEMINI ENTERPRISE AGENT PLATFORM</a:t>
             </a:r>
           </a:p>
         </p:txBody>
@@ -3279,8 +3281,8 @@
         </p:nvSpPr>
         <p:spPr>
           <a:xfrm>
-            <a:off x="548640" y="1417320"/>
-            <a:ext cx="5486400" cy="1097280"/>
+            <a:off x="914400" y="1783080"/>
+            <a:ext cx="10362895" cy="1188720"/>
           </a:xfrm>
           <a:prstGeom prst="rect">
             <a:avLst/>
@@ -3293,17 +3295,18 @@
           </a:bodyPr>
           <a:lstStyle/>
           <a:p>
-            <a:r>
-              <a:rPr sz="3000" b="0">
+            <a:pPr algn="ctr"/>
+            <a:r>
+              <a:rPr sz="4200">
                 <a:solidFill>
                   <a:srgbClr val="202124"/>
                 </a:solidFill>
                 <a:latin typeface="Arial"/>
               </a:rPr>
-              <a:t>Evaluating agents on the </a:t>
-            </a:r>
-            <a:r>
-              <a:rPr sz="3000" b="0">
+              <a:t>Evaluating Agents on the </a:t>
+            </a:r>
+            <a:r>
+              <a:rPr sz="4200">
                 <a:solidFill>
                   <a:srgbClr val="1A73E8"/>
                 </a:solidFill>
@@ -3322,8 +3325,8 @@
         </p:nvSpPr>
         <p:spPr>
           <a:xfrm>
-            <a:off x="548640" y="2514600"/>
-            <a:ext cx="5486400" cy="822960"/>
+            <a:off x="1737360" y="3063240"/>
+            <a:ext cx="8716975" cy="914400"/>
           </a:xfrm>
           <a:prstGeom prst="rect">
             <a:avLst/>
@@ -3336,13 +3339,14 @@
           </a:bodyPr>
           <a:lstStyle/>
           <a:p>
-            <a:r>
-              <a:rPr sz="1300">
+            <a:pPr algn="ctr"/>
+            <a:r>
+              <a:rPr sz="1500">
                 <a:solidFill>
                   <a:srgbClr val="5F6368"/>
                 </a:solidFill>
               </a:rPr>
-              <a:t>Turn “it seems to work” into measured quality. Evaluation runs as a continuous loop across four phases — Design › Execution › Scoring › Refinement.</a:t>
+              <a:t>The Quality Flywheel. Measure, monitor, and keep improving agent quality end to end. A hands-on walkthrough that covers everything in the Optimize / Evaluation docs, run against real deployed agents.</a:t>
             </a:r>
           </a:p>
         </p:txBody>
@@ -3355,8 +3359,8 @@
         </p:nvSpPr>
         <p:spPr>
           <a:xfrm>
-            <a:off x="548640" y="3383280"/>
-            <a:ext cx="5486400" cy="1828800"/>
+            <a:off x="1371600" y="4023360"/>
+            <a:ext cx="9448495" cy="502920"/>
           </a:xfrm>
           <a:prstGeom prst="rect">
             <a:avLst/>
@@ -3369,188 +3373,90 @@
           </a:bodyPr>
           <a:lstStyle/>
           <a:p>
-            <a:pPr>
-              <a:spcAft>
-                <a:spcPts val="800"/>
-              </a:spcAft>
-            </a:pPr>
-            <a:r>
-              <a:rPr sz="1000">
-                <a:solidFill>
-                  <a:srgbClr val="1A73E8"/>
-                </a:solidFill>
-              </a:rPr>
-              <a:t>●  </a:t>
-            </a:r>
-            <a:r>
-              <a:rPr sz="1250" b="1">
-                <a:solidFill>
-                  <a:srgbClr val="202124"/>
-                </a:solidFill>
-                <a:latin typeface="Arial"/>
-              </a:rPr>
-              <a:t>Define</a:t>
-            </a:r>
-            <a:r>
-              <a:rPr sz="1250" b="0">
-                <a:solidFill>
-                  <a:srgbClr val="3C4043"/>
-                </a:solidFill>
-                <a:latin typeface="Arial"/>
-              </a:rPr>
-              <a:t> eval cases &amp; metrics → </a:t>
-            </a:r>
-            <a:r>
-              <a:rPr sz="1250" b="1">
-                <a:solidFill>
-                  <a:srgbClr val="202124"/>
-                </a:solidFill>
-                <a:latin typeface="Arial"/>
-              </a:rPr>
-              <a:t>run</a:t>
-            </a:r>
-            <a:r>
-              <a:rPr sz="1250" b="0">
-                <a:solidFill>
-                  <a:srgbClr val="3C4043"/>
-                </a:solidFill>
-                <a:latin typeface="Arial"/>
-              </a:rPr>
-              <a:t> inferences → </a:t>
-            </a:r>
-            <a:r>
-              <a:rPr sz="1250" b="1">
-                <a:solidFill>
-                  <a:srgbClr val="202124"/>
-                </a:solidFill>
-                <a:latin typeface="Arial"/>
-              </a:rPr>
-              <a:t>score</a:t>
-            </a:r>
-            <a:r>
-              <a:rPr sz="1250" b="0">
-                <a:solidFill>
-                  <a:srgbClr val="3C4043"/>
-                </a:solidFill>
-                <a:latin typeface="Arial"/>
-              </a:rPr>
-              <a:t> with autoraters → </a:t>
-            </a:r>
-            <a:r>
-              <a:rPr sz="1250" b="1">
-                <a:solidFill>
-                  <a:srgbClr val="202124"/>
-                </a:solidFill>
-                <a:latin typeface="Arial"/>
-              </a:rPr>
-              <a:t>analyze</a:t>
-            </a:r>
-            <a:r>
-              <a:rPr sz="1250" b="0">
-                <a:solidFill>
-                  <a:srgbClr val="3C4043"/>
-                </a:solidFill>
-                <a:latin typeface="Arial"/>
-              </a:rPr>
-              <a:t> &amp; </a:t>
-            </a:r>
-            <a:r>
-              <a:rPr sz="1250" b="1">
-                <a:solidFill>
-                  <a:srgbClr val="202124"/>
-                </a:solidFill>
-                <a:latin typeface="Arial"/>
-              </a:rPr>
-              <a:t>optimize</a:t>
-            </a:r>
-            <a:r>
-              <a:rPr sz="1250" b="0">
-                <a:solidFill>
-                  <a:srgbClr val="3C4043"/>
-                </a:solidFill>
-                <a:latin typeface="Arial"/>
-              </a:rPr>
-              <a:t>, then repeat.</a:t>
-            </a:r>
-          </a:p>
-          <a:p>
-            <a:pPr>
-              <a:spcAft>
-                <a:spcPts val="800"/>
-              </a:spcAft>
-            </a:pPr>
-            <a:r>
-              <a:rPr sz="1000">
-                <a:solidFill>
-                  <a:srgbClr val="1A73E8"/>
-                </a:solidFill>
-              </a:rPr>
-              <a:t>●  </a:t>
-            </a:r>
-            <a:r>
-              <a:rPr sz="1250" b="0">
-                <a:solidFill>
-                  <a:srgbClr val="3C4043"/>
-                </a:solidFill>
-                <a:latin typeface="Arial"/>
-              </a:rPr>
-              <a:t>Demonstrates </a:t>
-            </a:r>
-            <a:r>
-              <a:rPr sz="1250" b="1">
-                <a:solidFill>
-                  <a:srgbClr val="202124"/>
-                </a:solidFill>
-                <a:latin typeface="Arial"/>
-              </a:rPr>
-              <a:t>100% of the 9 “Optimize → Evaluation” doc pages</a:t>
-            </a:r>
-            <a:r>
-              <a:rPr sz="1250" b="0">
-                <a:solidFill>
-                  <a:srgbClr val="3C4043"/>
-                </a:solidFill>
-                <a:latin typeface="Arial"/>
-              </a:rPr>
-              <a:t> against real deployed agents.</a:t>
-            </a:r>
-          </a:p>
-          <a:p>
-            <a:pPr>
-              <a:spcAft>
-                <a:spcPts val="800"/>
-              </a:spcAft>
-            </a:pPr>
-            <a:r>
-              <a:rPr sz="1000">
-                <a:solidFill>
-                  <a:srgbClr val="1A73E8"/>
-                </a:solidFill>
-              </a:rPr>
-              <a:t>●  </a:t>
-            </a:r>
-            <a:r>
-              <a:rPr sz="1250" b="0">
-                <a:solidFill>
-                  <a:srgbClr val="3C4043"/>
-                </a:solidFill>
-                <a:latin typeface="Arial"/>
-              </a:rPr>
-              <a:t>Run it:  uv run python -m src.eval.demo.full_eval_demo --agent-id $AGENT_ENGINE_ID</a:t>
-            </a:r>
-          </a:p>
-        </p:txBody>
-      </p:sp>
-      <p:sp>
-        <p:nvSpPr>
-          <p:cNvPr id="9" name="TextBox 8"/>
+            <a:pPr algn="ctr"/>
+            <a:r>
+              <a:rPr sz="1300" b="0">
+                <a:solidFill>
+                  <a:srgbClr val="5F6368"/>
+                </a:solidFill>
+                <a:latin typeface="Arial"/>
+              </a:rPr>
+              <a:t>Design   ›   Execution   ›   Scoring   ›   Refinement</a:t>
+            </a:r>
+          </a:p>
+        </p:txBody>
+      </p:sp>
+      <p:sp>
+        <p:nvSpPr>
+          <p:cNvPr id="9" name="Rounded Rectangle 8"/>
+          <p:cNvSpPr/>
+          <p:nvPr/>
+        </p:nvSpPr>
+        <p:spPr>
+          <a:xfrm>
+            <a:off x="1737360" y="4572000"/>
+            <a:ext cx="8716975" cy="457200"/>
+          </a:xfrm>
+          <a:prstGeom prst="roundRect">
+            <a:avLst/>
+          </a:prstGeom>
+          <a:solidFill>
+            <a:srgbClr val="202124"/>
+          </a:solidFill>
+          <a:ln>
+            <a:noFill/>
+          </a:ln>
+        </p:spPr>
+        <p:style>
+          <a:lnRef idx="1">
+            <a:schemeClr val="accent1"/>
+          </a:lnRef>
+          <a:fillRef idx="3">
+            <a:schemeClr val="accent1"/>
+          </a:fillRef>
+          <a:effectRef idx="2">
+            <a:schemeClr val="accent1"/>
+          </a:effectRef>
+          <a:fontRef idx="minor">
+            <a:schemeClr val="lt1"/>
+          </a:fontRef>
+        </p:style>
+        <p:txBody>
+          <a:bodyPr rtlCol="0" anchor="ctr" wrap="square" lIns="152400" tIns="25400" bIns="25400"/>
+          <a:lstStyle/>
+          <a:p>
+            <a:pPr algn="ctr"/>
+            <a:r>
+              <a:rPr sz="1200">
+                <a:solidFill>
+                  <a:srgbClr val="8AB4F8"/>
+                </a:solidFill>
+                <a:latin typeface="Consolas"/>
+              </a:rPr>
+              <a:t>$ </a:t>
+            </a:r>
+            <a:r>
+              <a:rPr sz="1200">
+                <a:solidFill>
+                  <a:srgbClr val="E8EAED"/>
+                </a:solidFill>
+                <a:latin typeface="Consolas"/>
+              </a:rPr>
+              <a:t>uv run python -m src.eval.demo.full_eval_demo --agent-id $AGENT_ENGINE_ID</a:t>
+            </a:r>
+          </a:p>
+        </p:txBody>
+      </p:sp>
+      <p:sp>
+        <p:nvSpPr>
+          <p:cNvPr id="10" name="TextBox 9"/>
           <p:cNvSpPr txBox="1"/>
           <p:nvPr/>
         </p:nvSpPr>
         <p:spPr>
           <a:xfrm>
-            <a:off x="548640" y="5532120"/>
-            <a:ext cx="5486400" cy="292608"/>
+            <a:off x="914400" y="5230368"/>
+            <a:ext cx="10362895" cy="365760"/>
           </a:xfrm>
           <a:prstGeom prst="rect">
             <a:avLst/>
@@ -3563,6 +3469,7 @@
           </a:bodyPr>
           <a:lstStyle/>
           <a:p>
+            <a:pPr algn="ctr"/>
             <a:r>
               <a:rPr sz="1200">
                 <a:solidFill>
@@ -3570,85 +3477,45 @@
                 </a:solidFill>
                 <a:hlinkClick r:id="rId2"/>
               </a:rPr>
-              <a:t>Docs: Agent evaluation overview ↗</a:t>
-            </a:r>
-          </a:p>
-        </p:txBody>
-      </p:sp>
-      <p:sp>
-        <p:nvSpPr>
-          <p:cNvPr id="10" name="TextBox 9"/>
-          <p:cNvSpPr txBox="1"/>
-          <p:nvPr/>
-        </p:nvSpPr>
-        <p:spPr>
-          <a:xfrm>
-            <a:off x="548640" y="5879592"/>
-            <a:ext cx="5486400" cy="914400"/>
-          </a:xfrm>
-          <a:prstGeom prst="rect">
-            <a:avLst/>
-          </a:prstGeom>
-          <a:noFill/>
-        </p:spPr>
-        <p:txBody>
-          <a:bodyPr wrap="square" anchor="t" lIns="0" rIns="0" tIns="0" bIns="0">
-            <a:spAutoFit/>
-          </a:bodyPr>
-          <a:lstStyle/>
-          <a:p>
-            <a:r>
-              <a:rPr sz="1100">
-                <a:solidFill>
-                  <a:srgbClr val="1967D2"/>
-                </a:solidFill>
-                <a:latin typeface="Consolas"/>
+              <a:t>Docs: Optimize / Evaluation ↗</a:t>
+            </a:r>
+            <a:r>
+              <a:rPr sz="1200">
+                <a:solidFill>
+                  <a:srgbClr val="5F6368"/>
+                </a:solidFill>
+              </a:rPr>
+              <a:t>      ·      </a:t>
+            </a:r>
+            <a:r>
+              <a:rPr sz="1200">
+                <a:solidFill>
+                  <a:srgbClr val="1A73E8"/>
+                </a:solidFill>
                 <a:hlinkClick r:id="rId3"/>
               </a:rPr>
-              <a:t>&lt;/&gt; docs/evaluation_demo.md    </a:t>
-            </a:r>
-            <a:r>
-              <a:rPr sz="1100">
-                <a:solidFill>
-                  <a:srgbClr val="1967D2"/>
-                </a:solidFill>
-                <a:latin typeface="Consolas"/>
+              <a:t>github.com/jswortz/geap-tour ↗</a:t>
+            </a:r>
+            <a:r>
+              <a:rPr sz="1200">
+                <a:solidFill>
+                  <a:srgbClr val="5F6368"/>
+                </a:solidFill>
+              </a:rPr>
+              <a:t>      ·      </a:t>
+            </a:r>
+            <a:r>
+              <a:rPr sz="1200">
+                <a:solidFill>
+                  <a:srgbClr val="1A73E8"/>
+                </a:solidFill>
                 <a:hlinkClick r:id="rId4"/>
               </a:rPr>
-              <a:t>&lt;/&gt; docs/eval_operations.md    </a:t>
-            </a:r>
-          </a:p>
-        </p:txBody>
-      </p:sp>
-      <p:pic>
-        <p:nvPicPr>
-          <p:cNvPr id="11" name="Picture 10" descr="eval_console_evaluation.png"/>
-          <p:cNvPicPr>
-            <a:picLocks noChangeAspect="1"/>
-          </p:cNvPicPr>
-          <p:nvPr/>
-        </p:nvPicPr>
-        <p:blipFill>
-          <a:blip r:embed="rId5"/>
-          <a:stretch>
-            <a:fillRect/>
-          </a:stretch>
-        </p:blipFill>
-        <p:spPr>
-          <a:xfrm>
-            <a:off x="6355080" y="1051560"/>
-            <a:ext cx="5486400" cy="3086100"/>
-          </a:xfrm>
-          <a:prstGeom prst="rect">
-            <a:avLst/>
-          </a:prstGeom>
-          <a:ln w="12700">
-            <a:solidFill>
-              <a:srgbClr val="DADCE0"/>
-            </a:solidFill>
-          </a:ln>
-        </p:spPr>
-      </p:pic>
+              <a:t>Demo walkthrough ↗</a:t>
+            </a:r>
+          </a:p>
+        </p:txBody>
+      </p:sp>
     </p:spTree>
   </p:cSld>
   <p:clrMapOvr>
@@ -3756,7 +3623,7 @@
                   <a:srgbClr val="5F6368"/>
                 </a:solidFill>
               </a:rPr>
-              <a:t>Phase 1 · Design</a:t>
+              <a:t>Gemini Enterprise Agent Platform › Optimize › Evaluation</a:t>
             </a:r>
           </a:p>
         </p:txBody>
@@ -3769,8 +3636,8 @@
         </p:nvSpPr>
         <p:spPr>
           <a:xfrm>
-            <a:off x="10698480" y="146304"/>
-            <a:ext cx="1005840" cy="365760"/>
+            <a:off x="10607040" y="146304"/>
+            <a:ext cx="1097280" cy="365760"/>
           </a:xfrm>
           <a:prstGeom prst="rect">
             <a:avLst/>
@@ -3790,7 +3657,7 @@
                   <a:srgbClr val="1967D2"/>
                 </a:solidFill>
               </a:rPr>
-              <a:t>2 / 5</a:t>
+              <a:t>2 / 7</a:t>
             </a:r>
           </a:p>
         </p:txBody>
@@ -3804,7 +3671,7 @@
         <p:spPr>
           <a:xfrm>
             <a:off x="548640" y="960120"/>
-            <a:ext cx="4023360" cy="310896"/>
+            <a:ext cx="3017520" cy="329184"/>
           </a:xfrm>
           <a:prstGeom prst="roundRect">
             <a:avLst/>
@@ -3841,7 +3708,7 @@
                   <a:srgbClr val="1967D2"/>
                 </a:solidFill>
               </a:rPr>
-              <a:t>DEFINE “GOOD” · METRIC REGISTRY</a:t>
+              <a:t>THE QUALITY FLYWHEEL</a:t>
             </a:r>
           </a:p>
         </p:txBody>
@@ -3869,31 +3736,22 @@
           <a:lstStyle/>
           <a:p>
             <a:r>
-              <a:rPr sz="3000" b="0">
+              <a:rPr sz="3000">
                 <a:solidFill>
                   <a:srgbClr val="202124"/>
                 </a:solidFill>
                 <a:latin typeface="Arial"/>
               </a:rPr>
-              <a:t>Pick — or </a:t>
-            </a:r>
-            <a:r>
-              <a:rPr sz="3000" b="0">
+              <a:t>Evaluating agents on the </a:t>
+            </a:r>
+            <a:r>
+              <a:rPr sz="3000">
                 <a:solidFill>
                   <a:srgbClr val="1A73E8"/>
                 </a:solidFill>
                 <a:latin typeface="Arial"/>
               </a:rPr>
-              <a:t>write</a:t>
-            </a:r>
-            <a:r>
-              <a:rPr sz="3000" b="0">
-                <a:solidFill>
-                  <a:srgbClr val="202124"/>
-                </a:solidFill>
-                <a:latin typeface="Arial"/>
-              </a:rPr>
-              <a:t> — your metrics</a:t>
+              <a:t>Agent Platform</a:t>
             </a:r>
           </a:p>
         </p:txBody>
@@ -3926,7 +3784,7 @@
                   <a:srgbClr val="5F6368"/>
                 </a:solidFill>
               </a:rPr>
-              <a:t>Define a metric once, reuse it across offline runs and online monitors. Three metric types, plus reference-based vs reference-free.</a:t>
+              <a:t>Turn “it seems to work” into something you can measure. Evaluation is a loop across four phases: Design, Execution, Scoring, Refinement.</a:t>
             </a:r>
           </a:p>
         </p:txBody>
@@ -3973,7 +3831,7 @@
                 </a:solidFill>
                 <a:latin typeface="Arial"/>
               </a:rPr>
-              <a:t>Predefined rubric</a:t>
+              <a:t>Define</a:t>
             </a:r>
             <a:r>
               <a:rPr sz="1250" b="0">
@@ -3982,7 +3840,79 @@
                 </a:solidFill>
                 <a:latin typeface="Arial"/>
               </a:rPr>
-              <a:t> — single-turn (Final Response Quality, Hallucination, Tool Use, Safety) &amp; multi-turn (Task Success, Tool Use, Trajectory).</a:t>
+              <a:t> eval cases and metrics, </a:t>
+            </a:r>
+            <a:r>
+              <a:rPr sz="1250" b="1">
+                <a:solidFill>
+                  <a:srgbClr val="202124"/>
+                </a:solidFill>
+                <a:latin typeface="Arial"/>
+              </a:rPr>
+              <a:t>run</a:t>
+            </a:r>
+            <a:r>
+              <a:rPr sz="1250" b="0">
+                <a:solidFill>
+                  <a:srgbClr val="3C4043"/>
+                </a:solidFill>
+                <a:latin typeface="Arial"/>
+              </a:rPr>
+              <a:t> inferences to produce traces, </a:t>
+            </a:r>
+            <a:r>
+              <a:rPr sz="1250" b="1">
+                <a:solidFill>
+                  <a:srgbClr val="202124"/>
+                </a:solidFill>
+                <a:latin typeface="Arial"/>
+              </a:rPr>
+              <a:t>score</a:t>
+            </a:r>
+            <a:r>
+              <a:rPr sz="1250" b="0">
+                <a:solidFill>
+                  <a:srgbClr val="3C4043"/>
+                </a:solidFill>
+                <a:latin typeface="Arial"/>
+              </a:rPr>
+              <a:t> them with autoraters, then </a:t>
+            </a:r>
+            <a:r>
+              <a:rPr sz="1250" b="1">
+                <a:solidFill>
+                  <a:srgbClr val="202124"/>
+                </a:solidFill>
+                <a:latin typeface="Arial"/>
+              </a:rPr>
+              <a:t>analyze</a:t>
+            </a:r>
+            <a:r>
+              <a:rPr sz="1250" b="0">
+                <a:solidFill>
+                  <a:srgbClr val="3C4043"/>
+                </a:solidFill>
+                <a:latin typeface="Arial"/>
+              </a:rPr>
+              <a:t> and </a:t>
+            </a:r>
+            <a:r>
+              <a:rPr sz="1250" b="1">
+                <a:solidFill>
+                  <a:srgbClr val="202124"/>
+                </a:solidFill>
+                <a:latin typeface="Arial"/>
+              </a:rPr>
+              <a:t>optimize</a:t>
+            </a:r>
+            <a:r>
+              <a:rPr sz="1250" b="0">
+                <a:solidFill>
+                  <a:srgbClr val="3C4043"/>
+                </a:solidFill>
+                <a:latin typeface="Arial"/>
+              </a:rPr>
+              <a:t>. Repeat.</a:t>
             </a:r>
           </a:p>
           <a:p>
@@ -4000,13 +3930,22 @@
               <a:t>●  </a:t>
             </a:r>
             <a:r>
+              <a:rPr sz="1250" b="0">
+                <a:solidFill>
+                  <a:srgbClr val="3C4043"/>
+                </a:solidFill>
+                <a:latin typeface="Arial"/>
+              </a:rPr>
+              <a:t>Covers </a:t>
+            </a:r>
+            <a:r>
               <a:rPr sz="1250" b="1">
                 <a:solidFill>
                   <a:srgbClr val="202124"/>
                 </a:solidFill>
                 <a:latin typeface="Arial"/>
               </a:rPr>
-              <a:t>Adaptive</a:t>
+              <a:t>all 9 of the “Optimize / Evaluation” doc pages</a:t>
             </a:r>
             <a:r>
               <a:rPr sz="1250" b="0">
@@ -4015,25 +3954,7 @@
                 </a:solidFill>
                 <a:latin typeface="Arial"/>
               </a:rPr>
-              <a:t> rubrics auto-generate criteria; </a:t>
-            </a:r>
-            <a:r>
-              <a:rPr sz="1250" b="1">
-                <a:solidFill>
-                  <a:srgbClr val="202124"/>
-                </a:solidFill>
-                <a:latin typeface="Arial"/>
-              </a:rPr>
-              <a:t>static</a:t>
-            </a:r>
-            <a:r>
-              <a:rPr sz="1250" b="0">
-                <a:solidFill>
-                  <a:srgbClr val="3C4043"/>
-                </a:solidFill>
-                <a:latin typeface="Arial"/>
-              </a:rPr>
-              <a:t> ones score 0–1.</a:t>
+              <a:t>, running against real deployed agents.</a:t>
             </a:r>
           </a:p>
           <a:p>
@@ -4051,91 +3972,13 @@
               <a:t>●  </a:t>
             </a:r>
             <a:r>
-              <a:rPr sz="1250" b="1">
-                <a:solidFill>
-                  <a:srgbClr val="202124"/>
-                </a:solidFill>
-                <a:latin typeface="Arial"/>
-              </a:rPr>
-              <a:t>Custom LLM-as-judge</a:t>
-            </a:r>
-            <a:r>
               <a:rPr sz="1250" b="0">
                 <a:solidFill>
                   <a:srgbClr val="3C4043"/>
                 </a:solidFill>
                 <a:latin typeface="Arial"/>
               </a:rPr>
-              <a:t> (types.LLMMetric) and </a:t>
-            </a:r>
-            <a:r>
-              <a:rPr sz="1250" b="1">
-                <a:solidFill>
-                  <a:srgbClr val="202124"/>
-                </a:solidFill>
-                <a:latin typeface="Arial"/>
-              </a:rPr>
-              <a:t>custom code</a:t>
-            </a:r>
-            <a:r>
-              <a:rPr sz="1250" b="0">
-                <a:solidFill>
-                  <a:srgbClr val="3C4043"/>
-                </a:solidFill>
-                <a:latin typeface="Arial"/>
-              </a:rPr>
-              <a:t> (types.CodeExecutionMetric).</a:t>
-            </a:r>
-          </a:p>
-          <a:p>
-            <a:pPr>
-              <a:spcAft>
-                <a:spcPts val="800"/>
-              </a:spcAft>
-            </a:pPr>
-            <a:r>
-              <a:rPr sz="1000">
-                <a:solidFill>
-                  <a:srgbClr val="1A73E8"/>
-                </a:solidFill>
-              </a:rPr>
-              <a:t>●  </a:t>
-            </a:r>
-            <a:r>
-              <a:rPr sz="1250" b="1">
-                <a:solidFill>
-                  <a:srgbClr val="202124"/>
-                </a:solidFill>
-                <a:latin typeface="Arial"/>
-              </a:rPr>
-              <a:t>Reference-based</a:t>
-            </a:r>
-            <a:r>
-              <a:rPr sz="1250" b="0">
-                <a:solidFill>
-                  <a:srgbClr val="3C4043"/>
-                </a:solidFill>
-                <a:latin typeface="Arial"/>
-              </a:rPr>
-              <a:t> Exact Match vs </a:t>
-            </a:r>
-            <a:r>
-              <a:rPr sz="1250" b="1">
-                <a:solidFill>
-                  <a:srgbClr val="202124"/>
-                </a:solidFill>
-                <a:latin typeface="Arial"/>
-              </a:rPr>
-              <a:t>reference-free</a:t>
-            </a:r>
-            <a:r>
-              <a:rPr sz="1250" b="0">
-                <a:solidFill>
-                  <a:srgbClr val="3C4043"/>
-                </a:solidFill>
-                <a:latin typeface="Arial"/>
-              </a:rPr>
-              <a:t> rubrics.</a:t>
+              <a:t>Run it:  uv run python -m src.eval.demo.full_eval_demo --agent-id $AGENT_ENGINE_ID</a:t>
             </a:r>
           </a:p>
         </p:txBody>
@@ -4169,7 +4012,7 @@
                 </a:solidFill>
                 <a:hlinkClick r:id="rId2"/>
               </a:rPr>
-              <a:t>Docs: Manage evaluation metrics ↗</a:t>
+              <a:t>Docs: Agent evaluation overview ↗</a:t>
             </a:r>
           </a:p>
         </p:txBody>
@@ -4204,7 +4047,7 @@
                 <a:latin typeface="Consolas"/>
                 <a:hlinkClick r:id="rId3"/>
               </a:rPr>
-              <a:t>&lt;/&gt; src/eval/metric_registry.py    </a:t>
+              <a:t>&lt;/&gt; docs/evaluation_demo.md    </a:t>
             </a:r>
             <a:r>
               <a:rPr sz="1100">
@@ -4214,14 +4057,14 @@
                 <a:latin typeface="Consolas"/>
                 <a:hlinkClick r:id="rId4"/>
               </a:rPr>
-              <a:t>&lt;/&gt; src/eval/agent_eval_configs.py    </a:t>
+              <a:t>&lt;/&gt; docs/eval_operations.md    </a:t>
             </a:r>
           </a:p>
         </p:txBody>
       </p:sp>
       <p:pic>
         <p:nvPicPr>
-          <p:cNvPr id="11" name="Picture 10" descr="eval_console_metrics_tab.png"/>
+          <p:cNvPr id="11" name="Picture 10" descr="eval_console_evaluation.png"/>
           <p:cNvPicPr>
             <a:picLocks noChangeAspect="1"/>
           </p:cNvPicPr>
@@ -4355,7 +4198,7 @@
                   <a:srgbClr val="5F6368"/>
                 </a:solidFill>
               </a:rPr>
-              <a:t>Phase 2 · Execution</a:t>
+              <a:t>Phase 1 · Design</a:t>
             </a:r>
           </a:p>
         </p:txBody>
@@ -4368,8 +4211,8 @@
         </p:nvSpPr>
         <p:spPr>
           <a:xfrm>
-            <a:off x="10698480" y="146304"/>
-            <a:ext cx="1005840" cy="365760"/>
+            <a:off x="10607040" y="146304"/>
+            <a:ext cx="1097280" cy="365760"/>
           </a:xfrm>
           <a:prstGeom prst="rect">
             <a:avLst/>
@@ -4389,7 +4232,7 @@
                   <a:srgbClr val="1967D2"/>
                 </a:solidFill>
               </a:rPr>
-              <a:t>3 / 5</a:t>
+              <a:t>3 / 7</a:t>
             </a:r>
           </a:p>
         </p:txBody>
@@ -4403,7 +4246,7 @@
         <p:spPr>
           <a:xfrm>
             <a:off x="548640" y="960120"/>
-            <a:ext cx="2377440" cy="310896"/>
+            <a:ext cx="4023360" cy="329184"/>
           </a:xfrm>
           <a:prstGeom prst="roundRect">
             <a:avLst/>
@@ -4440,7 +4283,7 @@
                   <a:srgbClr val="1967D2"/>
                 </a:solidFill>
               </a:rPr>
-              <a:t>GENERATE TRACES</a:t>
+              <a:t>DEFINE “GOOD” · METRIC REGISTRY</a:t>
             </a:r>
           </a:p>
         </p:txBody>
@@ -4468,31 +4311,31 @@
           <a:lstStyle/>
           <a:p>
             <a:r>
-              <a:rPr sz="3000" b="0">
+              <a:rPr sz="3000">
                 <a:solidFill>
                   <a:srgbClr val="202124"/>
                 </a:solidFill>
                 <a:latin typeface="Arial"/>
               </a:rPr>
-              <a:t>Three ways to </a:t>
-            </a:r>
-            <a:r>
-              <a:rPr sz="3000" b="0">
+              <a:t>Pick a metric, or </a:t>
+            </a:r>
+            <a:r>
+              <a:rPr sz="3000">
                 <a:solidFill>
                   <a:srgbClr val="1A73E8"/>
                 </a:solidFill>
                 <a:latin typeface="Arial"/>
               </a:rPr>
-              <a:t>exercise</a:t>
-            </a:r>
-            <a:r>
-              <a:rPr sz="3000" b="0">
+              <a:t>write</a:t>
+            </a:r>
+            <a:r>
+              <a:rPr sz="3000">
                 <a:solidFill>
                   <a:srgbClr val="202124"/>
                 </a:solidFill>
                 <a:latin typeface="Arial"/>
               </a:rPr>
-              <a:t> the agent</a:t>
+              <a:t> your own</a:t>
             </a:r>
           </a:p>
         </p:txBody>
@@ -4525,7 +4368,7 @@
                   <a:srgbClr val="5F6368"/>
                 </a:solidFill>
               </a:rPr>
-              <a:t>A trace is the immutable record of a run — model inputs, responses, tool calls. Produce them however fits the stage.</a:t>
+              <a:t>Define a metric once and reuse it across offline runs and online monitors. There are three kinds, plus the split between reference-based and reference-free.</a:t>
             </a:r>
           </a:p>
         </p:txBody>
@@ -4572,7 +4415,7 @@
                 </a:solidFill>
                 <a:latin typeface="Arial"/>
               </a:rPr>
-              <a:t>Batch / Test-case</a:t>
+              <a:t>Predefined rubric</a:t>
             </a:r>
             <a:r>
               <a:rPr sz="1250" b="0">
@@ -4581,7 +4424,7 @@
                 </a:solidFill>
                 <a:latin typeface="Arial"/>
               </a:rPr>
-              <a:t> — run inference over a fixed suite for regression testing (CI gate).</a:t>
+              <a:t>: single-turn (Final Response Quality, Hallucination, Tool Use, Safety) and multi-turn (Task Success, Tool Use, Trajectory).</a:t>
             </a:r>
           </a:p>
           <a:p>
@@ -4605,7 +4448,7 @@
                 </a:solidFill>
                 <a:latin typeface="Arial"/>
               </a:rPr>
-              <a:t>Simulated</a:t>
+              <a:t>Adaptive</a:t>
             </a:r>
             <a:r>
               <a:rPr sz="1250" b="0">
@@ -4614,7 +4457,25 @@
                 </a:solidFill>
                 <a:latin typeface="Arial"/>
               </a:rPr>
-              <a:t> — auto-generate multi-turn scenarios; an LLM role-plays the user, grounded by environment_context; inject mocked tools &amp; 503s.</a:t>
+              <a:t> rubrics write their own criteria; </a:t>
+            </a:r>
+            <a:r>
+              <a:rPr sz="1250" b="1">
+                <a:solidFill>
+                  <a:srgbClr val="202124"/>
+                </a:solidFill>
+                <a:latin typeface="Arial"/>
+              </a:rPr>
+              <a:t>static</a:t>
+            </a:r>
+            <a:r>
+              <a:rPr sz="1250" b="0">
+                <a:solidFill>
+                  <a:srgbClr val="3C4043"/>
+                </a:solidFill>
+                <a:latin typeface="Arial"/>
+              </a:rPr>
+              <a:t> ones score 0 to 1.</a:t>
             </a:r>
           </a:p>
           <a:p>
@@ -4638,7 +4499,7 @@
                 </a:solidFill>
                 <a:latin typeface="Arial"/>
               </a:rPr>
-              <a:t>Offline</a:t>
+              <a:t>Custom LLM-as-judge</a:t>
             </a:r>
             <a:r>
               <a:rPr sz="1250" b="0">
@@ -4647,7 +4508,7 @@
                 </a:solidFill>
                 <a:latin typeface="Arial"/>
               </a:rPr>
-              <a:t> — score </a:t>
+              <a:t> (types.LLMMetric) and </a:t>
             </a:r>
             <a:r>
               <a:rPr sz="1250" b="1">
@@ -4656,7 +4517,7 @@
                 </a:solidFill>
                 <a:latin typeface="Arial"/>
               </a:rPr>
-              <a:t>already-recorded</a:t>
+              <a:t>custom code</a:t>
             </a:r>
             <a:r>
               <a:rPr sz="1250" b="0">
@@ -4665,7 +4526,22 @@
                 </a:solidFill>
                 <a:latin typeface="Arial"/>
               </a:rPr>
-              <a:t> historical traces/sessions from Cloud Trace → BigQuery, with </a:t>
+              <a:t> (types.CodeExecutionMetric).</a:t>
+            </a:r>
+          </a:p>
+          <a:p>
+            <a:pPr>
+              <a:spcAft>
+                <a:spcPts val="800"/>
+              </a:spcAft>
+            </a:pPr>
+            <a:r>
+              <a:rPr sz="1000">
+                <a:solidFill>
+                  <a:srgbClr val="1A73E8"/>
+                </a:solidFill>
+              </a:rPr>
+              <a:t>●  </a:t>
             </a:r>
             <a:r>
               <a:rPr sz="1250" b="1">
@@ -4674,7 +4550,7 @@
                 </a:solidFill>
                 <a:latin typeface="Arial"/>
               </a:rPr>
-              <a:t>no new inference</a:t>
+              <a:t>Reference-based</a:t>
             </a:r>
             <a:r>
               <a:rPr sz="1250" b="0">
@@ -4683,7 +4559,25 @@
                 </a:solidFill>
                 <a:latin typeface="Arial"/>
               </a:rPr>
-              <a:t>.</a:t>
+              <a:t> Exact Match vs </a:t>
+            </a:r>
+            <a:r>
+              <a:rPr sz="1250" b="1">
+                <a:solidFill>
+                  <a:srgbClr val="202124"/>
+                </a:solidFill>
+                <a:latin typeface="Arial"/>
+              </a:rPr>
+              <a:t>reference-free</a:t>
+            </a:r>
+            <a:r>
+              <a:rPr sz="1250" b="0">
+                <a:solidFill>
+                  <a:srgbClr val="3C4043"/>
+                </a:solidFill>
+                <a:latin typeface="Arial"/>
+              </a:rPr>
+              <a:t> rubrics.</a:t>
             </a:r>
           </a:p>
         </p:txBody>
@@ -4717,7 +4611,7 @@
                 </a:solidFill>
                 <a:hlinkClick r:id="rId2"/>
               </a:rPr>
-              <a:t>Docs: Run evaluation / Simulate / Offline ↗</a:t>
+              <a:t>Docs: Manage evaluation metrics ↗</a:t>
             </a:r>
           </a:p>
         </p:txBody>
@@ -4752,7 +4646,7 @@
                 <a:latin typeface="Consolas"/>
                 <a:hlinkClick r:id="rId3"/>
               </a:rPr>
-              <a:t>&lt;/&gt; multi_agent_batch_eval.py    </a:t>
+              <a:t>&lt;/&gt; src/eval/metric_registry.py    </a:t>
             </a:r>
             <a:r>
               <a:rPr sz="1100">
@@ -4762,41 +4656,21 @@
                 <a:latin typeface="Consolas"/>
                 <a:hlinkClick r:id="rId4"/>
               </a:rPr>
-              <a:t>&lt;/&gt; simulated_eval.py    </a:t>
-            </a:r>
-            <a:r>
-              <a:rPr sz="1100">
-                <a:solidFill>
-                  <a:srgbClr val="1967D2"/>
-                </a:solidFill>
-                <a:latin typeface="Consolas"/>
-                <a:hlinkClick r:id="rId5"/>
-              </a:rPr>
-              <a:t>&lt;/&gt; env_simulation.py    </a:t>
-            </a:r>
-            <a:r>
-              <a:rPr sz="1100">
-                <a:solidFill>
-                  <a:srgbClr val="1967D2"/>
-                </a:solidFill>
-                <a:latin typeface="Consolas"/>
-                <a:hlinkClick r:id="rId6"/>
-              </a:rPr>
-              <a:t>&lt;/&gt; offline_trace_eval.py    </a:t>
+              <a:t>&lt;/&gt; src/eval/agent_eval_configs.py    </a:t>
             </a:r>
           </a:p>
         </p:txBody>
       </p:sp>
       <p:pic>
         <p:nvPicPr>
-          <p:cNvPr id="11" name="Picture 10" descr="eval_console_agent_engines.png"/>
+          <p:cNvPr id="11" name="Picture 10" descr="eval_console_metrics_tab.png"/>
           <p:cNvPicPr>
             <a:picLocks noChangeAspect="1"/>
           </p:cNvPicPr>
           <p:nvPr/>
         </p:nvPicPr>
         <p:blipFill>
-          <a:blip r:embed="rId7"/>
+          <a:blip r:embed="rId5"/>
           <a:stretch>
             <a:fillRect/>
           </a:stretch>
@@ -4923,7 +4797,7 @@
                   <a:srgbClr val="5F6368"/>
                 </a:solidFill>
               </a:rPr>
-              <a:t>Phase 3 · Scoring in production</a:t>
+              <a:t>Phase 2 · Execution</a:t>
             </a:r>
           </a:p>
         </p:txBody>
@@ -4936,8 +4810,8 @@
         </p:nvSpPr>
         <p:spPr>
           <a:xfrm>
-            <a:off x="10698480" y="146304"/>
-            <a:ext cx="1005840" cy="365760"/>
+            <a:off x="10607040" y="146304"/>
+            <a:ext cx="1097280" cy="365760"/>
           </a:xfrm>
           <a:prstGeom prst="rect">
             <a:avLst/>
@@ -4957,7 +4831,7 @@
                   <a:srgbClr val="1967D2"/>
                 </a:solidFill>
               </a:rPr>
-              <a:t>4 / 5</a:t>
+              <a:t>4 / 7</a:t>
             </a:r>
           </a:p>
         </p:txBody>
@@ -4971,7 +4845,7 @@
         <p:spPr>
           <a:xfrm>
             <a:off x="548640" y="960120"/>
-            <a:ext cx="4023360" cy="310896"/>
+            <a:ext cx="2377440" cy="329184"/>
           </a:xfrm>
           <a:prstGeom prst="roundRect">
             <a:avLst/>
@@ -5008,7 +4882,7 @@
                   <a:srgbClr val="1967D2"/>
                 </a:solidFill>
               </a:rPr>
-              <a:t>CONTINUOUS EVAL &amp; GUARDRAILS</a:t>
+              <a:t>GENERATE TRACES</a:t>
             </a:r>
           </a:p>
         </p:txBody>
@@ -5036,22 +4910,31 @@
           <a:lstStyle/>
           <a:p>
             <a:r>
-              <a:rPr sz="3000" b="0">
+              <a:rPr sz="3000">
                 <a:solidFill>
                   <a:srgbClr val="202124"/>
                 </a:solidFill>
                 <a:latin typeface="Arial"/>
               </a:rPr>
-              <a:t>Watch quality </a:t>
-            </a:r>
-            <a:r>
-              <a:rPr sz="3000" b="0">
+              <a:t>Three ways to </a:t>
+            </a:r>
+            <a:r>
+              <a:rPr sz="3000">
                 <a:solidFill>
                   <a:srgbClr val="1A73E8"/>
                 </a:solidFill>
                 <a:latin typeface="Arial"/>
               </a:rPr>
-              <a:t>in production</a:t>
+              <a:t>exercise</a:t>
+            </a:r>
+            <a:r>
+              <a:rPr sz="3000">
+                <a:solidFill>
+                  <a:srgbClr val="202124"/>
+                </a:solidFill>
+                <a:latin typeface="Arial"/>
+              </a:rPr>
+              <a:t> the agent</a:t>
             </a:r>
           </a:p>
         </p:txBody>
@@ -5084,7 +4967,7 @@
                   <a:srgbClr val="5F6368"/>
                 </a:solidFill>
               </a:rPr>
-              <a:t>Online Monitors asynchronously score live traffic and export scores to Cloud Monitoring — so you catch quality drift before users do.</a:t>
+              <a:t>A trace is the record of one run: the model inputs, the responses, and the tool calls. Produce them whichever way fits the stage.</a:t>
             </a:r>
           </a:p>
         </p:txBody>
@@ -5131,7 +5014,7 @@
                 </a:solidFill>
                 <a:latin typeface="Arial"/>
               </a:rPr>
-              <a:t>Online Monitors</a:t>
+              <a:t>Batch / test-case</a:t>
             </a:r>
             <a:r>
               <a:rPr sz="1250" b="0">
@@ -5140,7 +5023,7 @@
                 </a:solidFill>
                 <a:latin typeface="Arial"/>
               </a:rPr>
-              <a:t> — a ~10-min Query → Evaluate → Report loop with configurable sampling; results land in Logging + Monitoring.</a:t>
+              <a:t>: run inference over a fixed suite for regression testing in CI.</a:t>
             </a:r>
           </a:p>
           <a:p>
@@ -5164,7 +5047,7 @@
                 </a:solidFill>
                 <a:latin typeface="Arial"/>
               </a:rPr>
-              <a:t>Metrics Explorer &amp; dashboards</a:t>
+              <a:t>Simulated</a:t>
             </a:r>
             <a:r>
               <a:rPr sz="1250" b="0">
@@ -5173,7 +5056,7 @@
                 </a:solidFill>
                 <a:latin typeface="Arial"/>
               </a:rPr>
-              <a:t> — every score is a first-class Cloud Monitoring metric (agent_eval/*, online_evaluator/scores) you can chart, compare &amp; share.</a:t>
+              <a:t>: generate multi-turn scenarios and let an LLM play the user, grounded by environment_context. Inject mocked tools or 503s.</a:t>
             </a:r>
           </a:p>
           <a:p>
@@ -5197,7 +5080,7 @@
                 </a:solidFill>
                 <a:latin typeface="Arial"/>
               </a:rPr>
-              <a:t>Quality-drift alerts</a:t>
+              <a:t>Offline</a:t>
             </a:r>
             <a:r>
               <a:rPr sz="1250" b="0">
@@ -5206,7 +5089,43 @@
                 </a:solidFill>
                 <a:latin typeface="Arial"/>
               </a:rPr>
-              <a:t> — per-monitor policy, dashboard “Recommended Alerts”, or programmatic gcloud / monitoring_v3.</a:t>
+              <a:t>: score </a:t>
+            </a:r>
+            <a:r>
+              <a:rPr sz="1250" b="1">
+                <a:solidFill>
+                  <a:srgbClr val="202124"/>
+                </a:solidFill>
+                <a:latin typeface="Arial"/>
+              </a:rPr>
+              <a:t>already-recorded</a:t>
+            </a:r>
+            <a:r>
+              <a:rPr sz="1250" b="0">
+                <a:solidFill>
+                  <a:srgbClr val="3C4043"/>
+                </a:solidFill>
+                <a:latin typeface="Arial"/>
+              </a:rPr>
+              <a:t> historical traces and sessions in Cloud Trace and BigQuery, with </a:t>
+            </a:r>
+            <a:r>
+              <a:rPr sz="1250" b="1">
+                <a:solidFill>
+                  <a:srgbClr val="202124"/>
+                </a:solidFill>
+                <a:latin typeface="Arial"/>
+              </a:rPr>
+              <a:t>no new inference</a:t>
+            </a:r>
+            <a:r>
+              <a:rPr sz="1250" b="0">
+                <a:solidFill>
+                  <a:srgbClr val="3C4043"/>
+                </a:solidFill>
+                <a:latin typeface="Arial"/>
+              </a:rPr>
+              <a:t>.</a:t>
             </a:r>
           </a:p>
         </p:txBody>
@@ -5240,7 +5159,7 @@
                 </a:solidFill>
                 <a:hlinkClick r:id="rId2"/>
               </a:rPr>
-              <a:t>Docs: Online monitors / Quality alerts ↗</a:t>
+              <a:t>Docs: Run evaluation / Simulate / Offline ↗</a:t>
             </a:r>
           </a:p>
         </p:txBody>
@@ -5275,7 +5194,7 @@
                 <a:latin typeface="Consolas"/>
                 <a:hlinkClick r:id="rId3"/>
               </a:rPr>
-              <a:t>&lt;/&gt; setup_online_evaluators.py    </a:t>
+              <a:t>&lt;/&gt; multi_agent_batch_eval.py    </a:t>
             </a:r>
             <a:r>
               <a:rPr sz="1100">
@@ -5285,7 +5204,7 @@
                 <a:latin typeface="Consolas"/>
                 <a:hlinkClick r:id="rId4"/>
               </a:rPr>
-              <a:t>&lt;/&gt; publish_metrics.py    </a:t>
+              <a:t>&lt;/&gt; simulated_eval.py    </a:t>
             </a:r>
             <a:r>
               <a:rPr sz="1100">
@@ -5295,43 +5214,24 @@
                 <a:latin typeface="Consolas"/>
                 <a:hlinkClick r:id="rId5"/>
               </a:rPr>
-              <a:t>&lt;/&gt; quality_alerts.py    </a:t>
+              <a:t>&lt;/&gt; env_simulation.py    </a:t>
+            </a:r>
+            <a:r>
+              <a:rPr sz="1100">
+                <a:solidFill>
+                  <a:srgbClr val="1967D2"/>
+                </a:solidFill>
+                <a:latin typeface="Consolas"/>
+                <a:hlinkClick r:id="rId6"/>
+              </a:rPr>
+              <a:t>&lt;/&gt; offline_trace_eval.py    </a:t>
             </a:r>
           </a:p>
         </p:txBody>
       </p:sp>
       <p:pic>
         <p:nvPicPr>
-          <p:cNvPr id="11" name="Picture 10" descr="eval_console_online_monitors.png"/>
-          <p:cNvPicPr>
-            <a:picLocks noChangeAspect="1"/>
-          </p:cNvPicPr>
-          <p:nvPr/>
-        </p:nvPicPr>
-        <p:blipFill>
-          <a:blip r:embed="rId6"/>
-          <a:stretch>
-            <a:fillRect/>
-          </a:stretch>
-        </p:blipFill>
-        <p:spPr>
-          <a:xfrm>
-            <a:off x="6619240" y="868680"/>
-            <a:ext cx="4958080" cy="2788920"/>
-          </a:xfrm>
-          <a:prstGeom prst="rect">
-            <a:avLst/>
-          </a:prstGeom>
-          <a:ln w="12700">
-            <a:solidFill>
-              <a:srgbClr val="DADCE0"/>
-            </a:solidFill>
-          </a:ln>
-        </p:spPr>
-      </p:pic>
-      <p:pic>
-        <p:nvPicPr>
-          <p:cNvPr id="12" name="Picture 11" descr="eval_console_metrics_dashboard.png"/>
+          <p:cNvPr id="11" name="Picture 10" descr="eval_console_agent_engines.png"/>
           <p:cNvPicPr>
             <a:picLocks noChangeAspect="1"/>
           </p:cNvPicPr>
@@ -5345,8 +5245,8 @@
         </p:blipFill>
         <p:spPr>
           <a:xfrm>
-            <a:off x="6619240" y="3794760"/>
-            <a:ext cx="4958080" cy="2788920"/>
+            <a:off x="6355080" y="1051560"/>
+            <a:ext cx="5486400" cy="3086100"/>
           </a:xfrm>
           <a:prstGeom prst="rect">
             <a:avLst/>
@@ -5465,7 +5365,7 @@
                   <a:srgbClr val="5F6368"/>
                 </a:solidFill>
               </a:rPr>
-              <a:t>Phase 4 · Refinement</a:t>
+              <a:t>Phase 3 · Scoring in production</a:t>
             </a:r>
           </a:p>
         </p:txBody>
@@ -5478,8 +5378,8 @@
         </p:nvSpPr>
         <p:spPr>
           <a:xfrm>
-            <a:off x="10698480" y="146304"/>
-            <a:ext cx="1005840" cy="365760"/>
+            <a:off x="10607040" y="146304"/>
+            <a:ext cx="1097280" cy="365760"/>
           </a:xfrm>
           <a:prstGeom prst="rect">
             <a:avLst/>
@@ -5499,7 +5399,7 @@
                   <a:srgbClr val="1967D2"/>
                 </a:solidFill>
               </a:rPr>
-              <a:t>5 / 5</a:t>
+              <a:t>5 / 7</a:t>
             </a:r>
           </a:p>
         </p:txBody>
@@ -5513,7 +5413,7 @@
         <p:spPr>
           <a:xfrm>
             <a:off x="548640" y="960120"/>
-            <a:ext cx="3913632" cy="310896"/>
+            <a:ext cx="4023360" cy="329184"/>
           </a:xfrm>
           <a:prstGeom prst="roundRect">
             <a:avLst/>
@@ -5550,7 +5450,7 @@
                   <a:srgbClr val="1967D2"/>
                 </a:solidFill>
               </a:rPr>
-              <a:t>ANALYZE → OPTIMIZE → REPEAT</a:t>
+              <a:t>CONTINUOUS EVAL &amp; GUARDRAILS</a:t>
             </a:r>
           </a:p>
         </p:txBody>
@@ -5578,22 +5478,22 @@
           <a:lstStyle/>
           <a:p>
             <a:r>
-              <a:rPr sz="3000" b="0">
+              <a:rPr sz="3000">
                 <a:solidFill>
                   <a:srgbClr val="202124"/>
                 </a:solidFill>
                 <a:latin typeface="Arial"/>
               </a:rPr>
-              <a:t>Close the </a:t>
-            </a:r>
-            <a:r>
-              <a:rPr sz="3000" b="0">
+              <a:t>Watch quality </a:t>
+            </a:r>
+            <a:r>
+              <a:rPr sz="3000">
                 <a:solidFill>
                   <a:srgbClr val="1A73E8"/>
                 </a:solidFill>
                 <a:latin typeface="Arial"/>
               </a:rPr>
-              <a:t>flywheel</a:t>
+              <a:t>in production</a:t>
             </a:r>
           </a:p>
         </p:txBody>
@@ -5626,7 +5526,7 @@
                   <a:srgbClr val="5F6368"/>
                 </a:solidFill>
               </a:rPr>
-              <a:t>Don’t just learn that the agent failed — learn why, then fix it automatically.</a:t>
+              <a:t>Online Monitors score live traffic as it comes in and send the scores to Cloud Monitoring, so you catch quality drift before users do.</a:t>
             </a:r>
           </a:p>
         </p:txBody>
@@ -5673,7 +5573,7 @@
                 </a:solidFill>
                 <a:latin typeface="Arial"/>
               </a:rPr>
-              <a:t>Analyze</a:t>
+              <a:t>Online Monitors</a:t>
             </a:r>
             <a:r>
               <a:rPr sz="1250" b="0">
@@ -5682,25 +5582,7 @@
                 </a:solidFill>
                 <a:latin typeface="Arial"/>
               </a:rPr>
-              <a:t> — generate_loss_clusters() groups failures into named </a:t>
-            </a:r>
-            <a:r>
-              <a:rPr sz="1250" b="1">
-                <a:solidFill>
-                  <a:srgbClr val="202124"/>
-                </a:solidFill>
-                <a:latin typeface="Arial"/>
-              </a:rPr>
-              <a:t>loss-pattern taxonomies</a:t>
-            </a:r>
-            <a:r>
-              <a:rPr sz="1250" b="0">
-                <a:solidFill>
-                  <a:srgbClr val="3C4043"/>
-                </a:solidFill>
-                <a:latin typeface="Arial"/>
-              </a:rPr>
-              <a:t> with a 3-level triage: summary → clusters → traces.</a:t>
+              <a:t>: a roughly 10-minute loop that queries traffic, evaluates it, and reports. Sampling is configurable, and results land in Logging and Monitoring.</a:t>
             </a:r>
           </a:p>
           <a:p>
@@ -5724,7 +5606,7 @@
                 </a:solidFill>
                 <a:latin typeface="Arial"/>
               </a:rPr>
-              <a:t>Optimize</a:t>
+              <a:t>Metrics Explorer and dashboards</a:t>
             </a:r>
             <a:r>
               <a:rPr sz="1250" b="0">
@@ -5733,43 +5615,7 @@
                 </a:solidFill>
                 <a:latin typeface="Arial"/>
               </a:rPr>
-              <a:t> — refine root instructions with </a:t>
-            </a:r>
-            <a:r>
-              <a:rPr sz="1250" b="1">
-                <a:solidFill>
-                  <a:srgbClr val="202124"/>
-                </a:solidFill>
-                <a:latin typeface="Arial"/>
-              </a:rPr>
-              <a:t>GEPA</a:t>
-            </a:r>
-            <a:r>
-              <a:rPr sz="1250" b="0">
-                <a:solidFill>
-                  <a:srgbClr val="3C4043"/>
-                </a:solidFill>
-                <a:latin typeface="Arial"/>
-              </a:rPr>
-              <a:t> or </a:t>
-            </a:r>
-            <a:r>
-              <a:rPr sz="1250" b="1">
-                <a:solidFill>
-                  <a:srgbClr val="202124"/>
-                </a:solidFill>
-                <a:latin typeface="Arial"/>
-              </a:rPr>
-              <a:t>SimplePromptOptimizer</a:t>
-            </a:r>
-            <a:r>
-              <a:rPr sz="1250" b="0">
-                <a:solidFill>
-                  <a:srgbClr val="3C4043"/>
-                </a:solidFill>
-                <a:latin typeface="Arial"/>
-              </a:rPr>
-              <a:t>; drive the loop from an assistant via agents-cli eval.</a:t>
+              <a:t>: every score becomes a Cloud Monitoring metric (agent_eval/*, online_evaluator/scores), so you can chart, compare, and share it.</a:t>
             </a:r>
           </a:p>
           <a:p>
@@ -5793,7 +5639,7 @@
                 </a:solidFill>
                 <a:latin typeface="Arial"/>
               </a:rPr>
-              <a:t>Clean by design</a:t>
+              <a:t>Quality-drift alerts</a:t>
             </a:r>
             <a:r>
               <a:rPr sz="1250" b="0">
@@ -5802,25 +5648,7 @@
                 </a:solidFill>
                 <a:latin typeface="Arial"/>
               </a:rPr>
-              <a:t> — current Google clients from PyPI, </a:t>
-            </a:r>
-            <a:r>
-              <a:rPr sz="1250" b="1">
-                <a:solidFill>
-                  <a:srgbClr val="202124"/>
-                </a:solidFill>
-                <a:latin typeface="Arial"/>
-              </a:rPr>
-              <a:t>zero monkey-patching</a:t>
-            </a:r>
-            <a:r>
-              <a:rPr sz="1250" b="0">
-                <a:solidFill>
-                  <a:srgbClr val="3C4043"/>
-                </a:solidFill>
-                <a:latin typeface="Arial"/>
-              </a:rPr>
-              <a:t>, 161 tests green.</a:t>
+              <a:t>: a per-monitor policy, the dashboard's Recommended Alerts, or gcloud / monitoring_v3.</a:t>
             </a:r>
           </a:p>
         </p:txBody>
@@ -5854,7 +5682,7 @@
                 </a:solidFill>
                 <a:hlinkClick r:id="rId2"/>
               </a:rPr>
-              <a:t>Docs: Analyze results / Optimize agent ↗</a:t>
+              <a:t>Docs: Online monitors / Quality alerts ↗</a:t>
             </a:r>
           </a:p>
         </p:txBody>
@@ -5889,7 +5717,7 @@
                 <a:latin typeface="Consolas"/>
                 <a:hlinkClick r:id="rId3"/>
               </a:rPr>
-              <a:t>&lt;/&gt; failure_clusters.py    </a:t>
+              <a:t>&lt;/&gt; setup_online_evaluators.py    </a:t>
             </a:r>
             <a:r>
               <a:rPr sz="1100">
@@ -5899,7 +5727,7 @@
                 <a:latin typeface="Consolas"/>
                 <a:hlinkClick r:id="rId4"/>
               </a:rPr>
-              <a:t>&lt;/&gt; loss_taxonomy.py    </a:t>
+              <a:t>&lt;/&gt; publish_metrics.py    </a:t>
             </a:r>
             <a:r>
               <a:rPr sz="1100">
@@ -5909,24 +5737,43 @@
                 <a:latin typeface="Consolas"/>
                 <a:hlinkClick r:id="rId5"/>
               </a:rPr>
-              <a:t>&lt;/&gt; sdk_optimize.py    </a:t>
-            </a:r>
-            <a:r>
-              <a:rPr sz="1100">
-                <a:solidFill>
-                  <a:srgbClr val="1967D2"/>
-                </a:solidFill>
-                <a:latin typeface="Consolas"/>
-                <a:hlinkClick r:id="rId6"/>
-              </a:rPr>
-              <a:t>&lt;/&gt; run_optimize.py    </a:t>
+              <a:t>&lt;/&gt; quality_alerts.py    </a:t>
             </a:r>
           </a:p>
         </p:txBody>
       </p:sp>
       <p:pic>
         <p:nvPicPr>
-          <p:cNvPr id="11" name="Picture 10" descr="eval_console_bigquery.png"/>
+          <p:cNvPr id="11" name="Picture 10" descr="eval_console_online_monitors.png"/>
+          <p:cNvPicPr>
+            <a:picLocks noChangeAspect="1"/>
+          </p:cNvPicPr>
+          <p:nvPr/>
+        </p:nvPicPr>
+        <p:blipFill>
+          <a:blip r:embed="rId6"/>
+          <a:stretch>
+            <a:fillRect/>
+          </a:stretch>
+        </p:blipFill>
+        <p:spPr>
+          <a:xfrm>
+            <a:off x="6619240" y="868680"/>
+            <a:ext cx="4958080" cy="2788920"/>
+          </a:xfrm>
+          <a:prstGeom prst="rect">
+            <a:avLst/>
+          </a:prstGeom>
+          <a:ln w="12700">
+            <a:solidFill>
+              <a:srgbClr val="DADCE0"/>
+            </a:solidFill>
+          </a:ln>
+        </p:spPr>
+      </p:pic>
+      <p:pic>
+        <p:nvPicPr>
+          <p:cNvPr id="12" name="Picture 11" descr="eval_console_metrics_dashboard.png"/>
           <p:cNvPicPr>
             <a:picLocks noChangeAspect="1"/>
           </p:cNvPicPr>
@@ -5940,8 +5787,8 @@
         </p:blipFill>
         <p:spPr>
           <a:xfrm>
-            <a:off x="6355080" y="1051560"/>
-            <a:ext cx="5486400" cy="3086100"/>
+            <a:off x="6619240" y="3794760"/>
+            <a:ext cx="4958080" cy="2788920"/>
           </a:xfrm>
           <a:prstGeom prst="rect">
             <a:avLst/>
@@ -5953,6 +5800,1152 @@
           </a:ln>
         </p:spPr>
       </p:pic>
+    </p:spTree>
+  </p:cSld>
+  <p:clrMapOvr>
+    <a:masterClrMapping/>
+  </p:clrMapOvr>
+</p:sld>
+</file>
+
+<file path=ppt/slides/slide6.xml><?xml version="1.0" encoding="utf-8"?>
+<p:sld xmlns:a="http://schemas.openxmlformats.org/drawingml/2006/main" xmlns:p="http://schemas.openxmlformats.org/presentationml/2006/main" xmlns:r="http://schemas.openxmlformats.org/officeDocument/2006/relationships">
+  <p:cSld>
+    <p:bg>
+      <p:bgPr>
+        <a:solidFill>
+          <a:srgbClr val="F8F9FA"/>
+        </a:solidFill>
+        <a:effectLst/>
+      </p:bgPr>
+    </p:bg>
+    <p:spTree>
+      <p:nvGrpSpPr>
+        <p:cNvPr id="1" name=""/>
+        <p:cNvGrpSpPr/>
+        <p:nvPr/>
+      </p:nvGrpSpPr>
+      <p:grpSpPr/>
+      <p:sp>
+        <p:nvSpPr>
+          <p:cNvPr id="2" name="Rectangle 1"/>
+          <p:cNvSpPr/>
+          <p:nvPr/>
+        </p:nvSpPr>
+        <p:spPr>
+          <a:xfrm>
+            <a:off x="0" y="0"/>
+            <a:ext cx="12191695" cy="658368"/>
+          </a:xfrm>
+          <a:prstGeom prst="rect">
+            <a:avLst/>
+          </a:prstGeom>
+          <a:solidFill>
+            <a:srgbClr val="FFFFFF"/>
+          </a:solidFill>
+          <a:ln w="6350">
+            <a:solidFill>
+              <a:srgbClr val="DADCE0"/>
+            </a:solidFill>
+          </a:ln>
+        </p:spPr>
+        <p:style>
+          <a:lnRef idx="1">
+            <a:schemeClr val="accent1"/>
+          </a:lnRef>
+          <a:fillRef idx="3">
+            <a:schemeClr val="accent1"/>
+          </a:fillRef>
+          <a:effectRef idx="2">
+            <a:schemeClr val="accent1"/>
+          </a:effectRef>
+          <a:fontRef idx="minor">
+            <a:schemeClr val="lt1"/>
+          </a:fontRef>
+        </p:style>
+        <p:txBody>
+          <a:bodyPr rtlCol="0" anchor="ctr"/>
+          <a:lstStyle/>
+          <a:p>
+            <a:pPr algn="ctr"/>
+          </a:p>
+        </p:txBody>
+      </p:sp>
+      <p:sp>
+        <p:nvSpPr>
+          <p:cNvPr id="3" name="TextBox 2"/>
+          <p:cNvSpPr txBox="1"/>
+          <p:nvPr/>
+        </p:nvSpPr>
+        <p:spPr>
+          <a:xfrm>
+            <a:off x="502920" y="146304"/>
+            <a:ext cx="8686800" cy="365760"/>
+          </a:xfrm>
+          <a:prstGeom prst="rect">
+            <a:avLst/>
+          </a:prstGeom>
+          <a:noFill/>
+        </p:spPr>
+        <p:txBody>
+          <a:bodyPr wrap="square" anchor="ctr" lIns="0" rIns="0" tIns="0" bIns="0">
+            <a:spAutoFit/>
+          </a:bodyPr>
+          <a:lstStyle/>
+          <a:p>
+            <a:r>
+              <a:rPr sz="1300" b="1">
+                <a:solidFill>
+                  <a:srgbClr val="1A73E8"/>
+                </a:solidFill>
+              </a:rPr>
+              <a:t>☁ Google Cloud   </a:t>
+            </a:r>
+            <a:r>
+              <a:rPr sz="1100">
+                <a:solidFill>
+                  <a:srgbClr val="5F6368"/>
+                </a:solidFill>
+              </a:rPr>
+              <a:t>Phase 4 · Refinement</a:t>
+            </a:r>
+          </a:p>
+        </p:txBody>
+      </p:sp>
+      <p:sp>
+        <p:nvSpPr>
+          <p:cNvPr id="4" name="TextBox 3"/>
+          <p:cNvSpPr txBox="1"/>
+          <p:nvPr/>
+        </p:nvSpPr>
+        <p:spPr>
+          <a:xfrm>
+            <a:off x="10607040" y="146304"/>
+            <a:ext cx="1097280" cy="365760"/>
+          </a:xfrm>
+          <a:prstGeom prst="rect">
+            <a:avLst/>
+          </a:prstGeom>
+          <a:noFill/>
+        </p:spPr>
+        <p:txBody>
+          <a:bodyPr wrap="square" anchor="ctr" lIns="0" rIns="0" tIns="0" bIns="0">
+            <a:spAutoFit/>
+          </a:bodyPr>
+          <a:lstStyle/>
+          <a:p>
+            <a:pPr algn="r"/>
+            <a:r>
+              <a:rPr sz="1100" b="1">
+                <a:solidFill>
+                  <a:srgbClr val="1967D2"/>
+                </a:solidFill>
+              </a:rPr>
+              <a:t>6 / 7</a:t>
+            </a:r>
+          </a:p>
+        </p:txBody>
+      </p:sp>
+      <p:sp>
+        <p:nvSpPr>
+          <p:cNvPr id="5" name="Rounded Rectangle 4"/>
+          <p:cNvSpPr/>
+          <p:nvPr/>
+        </p:nvSpPr>
+        <p:spPr>
+          <a:xfrm>
+            <a:off x="548640" y="960120"/>
+            <a:ext cx="3657600" cy="329184"/>
+          </a:xfrm>
+          <a:prstGeom prst="roundRect">
+            <a:avLst/>
+          </a:prstGeom>
+          <a:solidFill>
+            <a:srgbClr val="E8F0FE"/>
+          </a:solidFill>
+          <a:ln>
+            <a:noFill/>
+          </a:ln>
+        </p:spPr>
+        <p:style>
+          <a:lnRef idx="1">
+            <a:schemeClr val="accent1"/>
+          </a:lnRef>
+          <a:fillRef idx="3">
+            <a:schemeClr val="accent1"/>
+          </a:fillRef>
+          <a:effectRef idx="2">
+            <a:schemeClr val="accent1"/>
+          </a:effectRef>
+          <a:fontRef idx="minor">
+            <a:schemeClr val="lt1"/>
+          </a:fontRef>
+        </p:style>
+        <p:txBody>
+          <a:bodyPr rtlCol="0" anchor="ctr" tIns="0" bIns="0"/>
+          <a:lstStyle/>
+          <a:p>
+            <a:pPr algn="ctr"/>
+            <a:r>
+              <a:rPr sz="1000" b="1">
+                <a:solidFill>
+                  <a:srgbClr val="1967D2"/>
+                </a:solidFill>
+              </a:rPr>
+              <a:t>ANALYZE, OPTIMIZE, REPEAT</a:t>
+            </a:r>
+          </a:p>
+        </p:txBody>
+      </p:sp>
+      <p:sp>
+        <p:nvSpPr>
+          <p:cNvPr id="6" name="TextBox 5"/>
+          <p:cNvSpPr txBox="1"/>
+          <p:nvPr/>
+        </p:nvSpPr>
+        <p:spPr>
+          <a:xfrm>
+            <a:off x="548640" y="1417320"/>
+            <a:ext cx="5486400" cy="1097280"/>
+          </a:xfrm>
+          <a:prstGeom prst="rect">
+            <a:avLst/>
+          </a:prstGeom>
+          <a:noFill/>
+        </p:spPr>
+        <p:txBody>
+          <a:bodyPr wrap="square" anchor="t" lIns="0" rIns="0" tIns="0" bIns="0">
+            <a:spAutoFit/>
+          </a:bodyPr>
+          <a:lstStyle/>
+          <a:p>
+            <a:r>
+              <a:rPr sz="3000">
+                <a:solidFill>
+                  <a:srgbClr val="202124"/>
+                </a:solidFill>
+                <a:latin typeface="Arial"/>
+              </a:rPr>
+              <a:t>Close the </a:t>
+            </a:r>
+            <a:r>
+              <a:rPr sz="3000">
+                <a:solidFill>
+                  <a:srgbClr val="1A73E8"/>
+                </a:solidFill>
+                <a:latin typeface="Arial"/>
+              </a:rPr>
+              <a:t>flywheel</a:t>
+            </a:r>
+          </a:p>
+        </p:txBody>
+      </p:sp>
+      <p:sp>
+        <p:nvSpPr>
+          <p:cNvPr id="7" name="TextBox 6"/>
+          <p:cNvSpPr txBox="1"/>
+          <p:nvPr/>
+        </p:nvSpPr>
+        <p:spPr>
+          <a:xfrm>
+            <a:off x="548640" y="2514600"/>
+            <a:ext cx="5486400" cy="822960"/>
+          </a:xfrm>
+          <a:prstGeom prst="rect">
+            <a:avLst/>
+          </a:prstGeom>
+          <a:noFill/>
+        </p:spPr>
+        <p:txBody>
+          <a:bodyPr wrap="square" anchor="t" lIns="0" rIns="0" tIns="0" bIns="0">
+            <a:spAutoFit/>
+          </a:bodyPr>
+          <a:lstStyle/>
+          <a:p>
+            <a:r>
+              <a:rPr sz="1300">
+                <a:solidFill>
+                  <a:srgbClr val="5F6368"/>
+                </a:solidFill>
+              </a:rPr>
+              <a:t>Don’t just learn that the agent failed. Learn why, then fix it.</a:t>
+            </a:r>
+          </a:p>
+        </p:txBody>
+      </p:sp>
+      <p:sp>
+        <p:nvSpPr>
+          <p:cNvPr id="8" name="TextBox 7"/>
+          <p:cNvSpPr txBox="1"/>
+          <p:nvPr/>
+        </p:nvSpPr>
+        <p:spPr>
+          <a:xfrm>
+            <a:off x="548640" y="3383280"/>
+            <a:ext cx="5486400" cy="1828800"/>
+          </a:xfrm>
+          <a:prstGeom prst="rect">
+            <a:avLst/>
+          </a:prstGeom>
+          <a:noFill/>
+        </p:spPr>
+        <p:txBody>
+          <a:bodyPr wrap="square" anchor="t" lIns="0" rIns="0" tIns="0" bIns="0">
+            <a:spAutoFit/>
+          </a:bodyPr>
+          <a:lstStyle/>
+          <a:p>
+            <a:pPr>
+              <a:spcAft>
+                <a:spcPts val="800"/>
+              </a:spcAft>
+            </a:pPr>
+            <a:r>
+              <a:rPr sz="1000">
+                <a:solidFill>
+                  <a:srgbClr val="1A73E8"/>
+                </a:solidFill>
+              </a:rPr>
+              <a:t>●  </a:t>
+            </a:r>
+            <a:r>
+              <a:rPr sz="1250" b="1">
+                <a:solidFill>
+                  <a:srgbClr val="202124"/>
+                </a:solidFill>
+                <a:latin typeface="Arial"/>
+              </a:rPr>
+              <a:t>Optimize</a:t>
+            </a:r>
+            <a:r>
+              <a:rPr sz="1250" b="0">
+                <a:solidFill>
+                  <a:srgbClr val="3C4043"/>
+                </a:solidFill>
+                <a:latin typeface="Arial"/>
+              </a:rPr>
+              <a:t>: refine root instructions with </a:t>
+            </a:r>
+            <a:r>
+              <a:rPr sz="1250" b="1">
+                <a:solidFill>
+                  <a:srgbClr val="202124"/>
+                </a:solidFill>
+                <a:latin typeface="Arial"/>
+              </a:rPr>
+              <a:t>GEPA</a:t>
+            </a:r>
+            <a:r>
+              <a:rPr sz="1250" b="0">
+                <a:solidFill>
+                  <a:srgbClr val="3C4043"/>
+                </a:solidFill>
+                <a:latin typeface="Arial"/>
+              </a:rPr>
+              <a:t> or </a:t>
+            </a:r>
+            <a:r>
+              <a:rPr sz="1250" b="1">
+                <a:solidFill>
+                  <a:srgbClr val="202124"/>
+                </a:solidFill>
+                <a:latin typeface="Arial"/>
+              </a:rPr>
+              <a:t>SimplePromptOptimizer</a:t>
+            </a:r>
+            <a:r>
+              <a:rPr sz="1250" b="0">
+                <a:solidFill>
+                  <a:srgbClr val="3C4043"/>
+                </a:solidFill>
+                <a:latin typeface="Arial"/>
+              </a:rPr>
+              <a:t>, or drive the loop from an assistant with agents-cli eval.</a:t>
+            </a:r>
+          </a:p>
+          <a:p>
+            <a:pPr>
+              <a:spcAft>
+                <a:spcPts val="800"/>
+              </a:spcAft>
+            </a:pPr>
+            <a:r>
+              <a:rPr sz="1000">
+                <a:solidFill>
+                  <a:srgbClr val="1A73E8"/>
+                </a:solidFill>
+              </a:rPr>
+              <a:t>●  </a:t>
+            </a:r>
+            <a:r>
+              <a:rPr sz="1250" b="1">
+                <a:solidFill>
+                  <a:srgbClr val="202124"/>
+                </a:solidFill>
+                <a:latin typeface="Arial"/>
+              </a:rPr>
+              <a:t>Re-evaluate</a:t>
+            </a:r>
+            <a:r>
+              <a:rPr sz="1250" b="0">
+                <a:solidFill>
+                  <a:srgbClr val="3C4043"/>
+                </a:solidFill>
+                <a:latin typeface="Arial"/>
+              </a:rPr>
+              <a:t>: score the tuned agent against the same suite and compare, closing the loop.</a:t>
+            </a:r>
+          </a:p>
+          <a:p>
+            <a:pPr>
+              <a:spcAft>
+                <a:spcPts val="800"/>
+              </a:spcAft>
+            </a:pPr>
+            <a:r>
+              <a:rPr sz="1000">
+                <a:solidFill>
+                  <a:srgbClr val="1A73E8"/>
+                </a:solidFill>
+              </a:rPr>
+              <a:t>●  </a:t>
+            </a:r>
+            <a:r>
+              <a:rPr sz="1250" b="1">
+                <a:solidFill>
+                  <a:srgbClr val="202124"/>
+                </a:solidFill>
+                <a:latin typeface="Arial"/>
+              </a:rPr>
+              <a:t>Built clean</a:t>
+            </a:r>
+            <a:r>
+              <a:rPr sz="1250" b="0">
+                <a:solidFill>
+                  <a:srgbClr val="3C4043"/>
+                </a:solidFill>
+                <a:latin typeface="Arial"/>
+              </a:rPr>
+              <a:t>: current Google clients from PyPI, </a:t>
+            </a:r>
+            <a:r>
+              <a:rPr sz="1250" b="1">
+                <a:solidFill>
+                  <a:srgbClr val="202124"/>
+                </a:solidFill>
+                <a:latin typeface="Arial"/>
+              </a:rPr>
+              <a:t>no monkey-patching</a:t>
+            </a:r>
+            <a:r>
+              <a:rPr sz="1250" b="0">
+                <a:solidFill>
+                  <a:srgbClr val="3C4043"/>
+                </a:solidFill>
+                <a:latin typeface="Arial"/>
+              </a:rPr>
+              <a:t>, and 161 passing tests.</a:t>
+            </a:r>
+          </a:p>
+        </p:txBody>
+      </p:sp>
+      <p:sp>
+        <p:nvSpPr>
+          <p:cNvPr id="9" name="TextBox 8"/>
+          <p:cNvSpPr txBox="1"/>
+          <p:nvPr/>
+        </p:nvSpPr>
+        <p:spPr>
+          <a:xfrm>
+            <a:off x="548640" y="5532120"/>
+            <a:ext cx="5486400" cy="292608"/>
+          </a:xfrm>
+          <a:prstGeom prst="rect">
+            <a:avLst/>
+          </a:prstGeom>
+          <a:noFill/>
+        </p:spPr>
+        <p:txBody>
+          <a:bodyPr wrap="square" anchor="t" lIns="0" rIns="0" tIns="0" bIns="0">
+            <a:spAutoFit/>
+          </a:bodyPr>
+          <a:lstStyle/>
+          <a:p>
+            <a:r>
+              <a:rPr sz="1200">
+                <a:solidFill>
+                  <a:srgbClr val="1A73E8"/>
+                </a:solidFill>
+                <a:hlinkClick r:id="rId2"/>
+              </a:rPr>
+              <a:t>Docs: Optimize agent prompts ↗</a:t>
+            </a:r>
+          </a:p>
+        </p:txBody>
+      </p:sp>
+      <p:sp>
+        <p:nvSpPr>
+          <p:cNvPr id="10" name="TextBox 9"/>
+          <p:cNvSpPr txBox="1"/>
+          <p:nvPr/>
+        </p:nvSpPr>
+        <p:spPr>
+          <a:xfrm>
+            <a:off x="548640" y="5879592"/>
+            <a:ext cx="5486400" cy="914400"/>
+          </a:xfrm>
+          <a:prstGeom prst="rect">
+            <a:avLst/>
+          </a:prstGeom>
+          <a:noFill/>
+        </p:spPr>
+        <p:txBody>
+          <a:bodyPr wrap="square" anchor="t" lIns="0" rIns="0" tIns="0" bIns="0">
+            <a:spAutoFit/>
+          </a:bodyPr>
+          <a:lstStyle/>
+          <a:p>
+            <a:r>
+              <a:rPr sz="1100">
+                <a:solidFill>
+                  <a:srgbClr val="1967D2"/>
+                </a:solidFill>
+                <a:latin typeface="Consolas"/>
+                <a:hlinkClick r:id="rId3"/>
+              </a:rPr>
+              <a:t>&lt;/&gt; sdk_optimize.py    </a:t>
+            </a:r>
+            <a:r>
+              <a:rPr sz="1100">
+                <a:solidFill>
+                  <a:srgbClr val="1967D2"/>
+                </a:solidFill>
+                <a:latin typeface="Consolas"/>
+                <a:hlinkClick r:id="rId4"/>
+              </a:rPr>
+              <a:t>&lt;/&gt; run_optimize.py    </a:t>
+            </a:r>
+            <a:r>
+              <a:rPr sz="1100">
+                <a:solidFill>
+                  <a:srgbClr val="1967D2"/>
+                </a:solidFill>
+                <a:latin typeface="Consolas"/>
+                <a:hlinkClick r:id="rId5"/>
+              </a:rPr>
+              <a:t>&lt;/&gt; agents_cli_demo.sh    </a:t>
+            </a:r>
+          </a:p>
+        </p:txBody>
+      </p:sp>
+      <p:pic>
+        <p:nvPicPr>
+          <p:cNvPr id="11" name="Picture 10" descr="eval_console_bigquery.png"/>
+          <p:cNvPicPr>
+            <a:picLocks noChangeAspect="1"/>
+          </p:cNvPicPr>
+          <p:nvPr/>
+        </p:nvPicPr>
+        <p:blipFill>
+          <a:blip r:embed="rId6"/>
+          <a:stretch>
+            <a:fillRect/>
+          </a:stretch>
+        </p:blipFill>
+        <p:spPr>
+          <a:xfrm>
+            <a:off x="6355080" y="1051560"/>
+            <a:ext cx="5486400" cy="3086100"/>
+          </a:xfrm>
+          <a:prstGeom prst="rect">
+            <a:avLst/>
+          </a:prstGeom>
+          <a:ln w="12700">
+            <a:solidFill>
+              <a:srgbClr val="DADCE0"/>
+            </a:solidFill>
+          </a:ln>
+        </p:spPr>
+      </p:pic>
+    </p:spTree>
+  </p:cSld>
+  <p:clrMapOvr>
+    <a:masterClrMapping/>
+  </p:clrMapOvr>
+</p:sld>
+</file>
+
+<file path=ppt/slides/slide7.xml><?xml version="1.0" encoding="utf-8"?>
+<p:sld xmlns:a="http://schemas.openxmlformats.org/drawingml/2006/main" xmlns:p="http://schemas.openxmlformats.org/presentationml/2006/main" xmlns:r="http://schemas.openxmlformats.org/officeDocument/2006/relationships">
+  <p:cSld>
+    <p:bg>
+      <p:bgPr>
+        <a:solidFill>
+          <a:srgbClr val="F8F9FA"/>
+        </a:solidFill>
+        <a:effectLst/>
+      </p:bgPr>
+    </p:bg>
+    <p:spTree>
+      <p:nvGrpSpPr>
+        <p:cNvPr id="1" name=""/>
+        <p:cNvGrpSpPr/>
+        <p:nvPr/>
+      </p:nvGrpSpPr>
+      <p:grpSpPr/>
+      <p:sp>
+        <p:nvSpPr>
+          <p:cNvPr id="2" name="Rectangle 1"/>
+          <p:cNvSpPr/>
+          <p:nvPr/>
+        </p:nvSpPr>
+        <p:spPr>
+          <a:xfrm>
+            <a:off x="0" y="0"/>
+            <a:ext cx="12191695" cy="658368"/>
+          </a:xfrm>
+          <a:prstGeom prst="rect">
+            <a:avLst/>
+          </a:prstGeom>
+          <a:solidFill>
+            <a:srgbClr val="FFFFFF"/>
+          </a:solidFill>
+          <a:ln w="6350">
+            <a:solidFill>
+              <a:srgbClr val="DADCE0"/>
+            </a:solidFill>
+          </a:ln>
+        </p:spPr>
+        <p:style>
+          <a:lnRef idx="1">
+            <a:schemeClr val="accent1"/>
+          </a:lnRef>
+          <a:fillRef idx="3">
+            <a:schemeClr val="accent1"/>
+          </a:fillRef>
+          <a:effectRef idx="2">
+            <a:schemeClr val="accent1"/>
+          </a:effectRef>
+          <a:fontRef idx="minor">
+            <a:schemeClr val="lt1"/>
+          </a:fontRef>
+        </p:style>
+        <p:txBody>
+          <a:bodyPr rtlCol="0" anchor="ctr"/>
+          <a:lstStyle/>
+          <a:p>
+            <a:pPr algn="ctr"/>
+          </a:p>
+        </p:txBody>
+      </p:sp>
+      <p:sp>
+        <p:nvSpPr>
+          <p:cNvPr id="3" name="TextBox 2"/>
+          <p:cNvSpPr txBox="1"/>
+          <p:nvPr/>
+        </p:nvSpPr>
+        <p:spPr>
+          <a:xfrm>
+            <a:off x="502920" y="146304"/>
+            <a:ext cx="8686800" cy="365760"/>
+          </a:xfrm>
+          <a:prstGeom prst="rect">
+            <a:avLst/>
+          </a:prstGeom>
+          <a:noFill/>
+        </p:spPr>
+        <p:txBody>
+          <a:bodyPr wrap="square" anchor="ctr" lIns="0" rIns="0" tIns="0" bIns="0">
+            <a:spAutoFit/>
+          </a:bodyPr>
+          <a:lstStyle/>
+          <a:p>
+            <a:r>
+              <a:rPr sz="1300" b="1">
+                <a:solidFill>
+                  <a:srgbClr val="1A73E8"/>
+                </a:solidFill>
+              </a:rPr>
+              <a:t>☁ Google Cloud   </a:t>
+            </a:r>
+            <a:r>
+              <a:rPr sz="1100">
+                <a:solidFill>
+                  <a:srgbClr val="5F6368"/>
+                </a:solidFill>
+              </a:rPr>
+              <a:t>Summary</a:t>
+            </a:r>
+          </a:p>
+        </p:txBody>
+      </p:sp>
+      <p:sp>
+        <p:nvSpPr>
+          <p:cNvPr id="4" name="TextBox 3"/>
+          <p:cNvSpPr txBox="1"/>
+          <p:nvPr/>
+        </p:nvSpPr>
+        <p:spPr>
+          <a:xfrm>
+            <a:off x="10607040" y="146304"/>
+            <a:ext cx="1097280" cy="365760"/>
+          </a:xfrm>
+          <a:prstGeom prst="rect">
+            <a:avLst/>
+          </a:prstGeom>
+          <a:noFill/>
+        </p:spPr>
+        <p:txBody>
+          <a:bodyPr wrap="square" anchor="ctr" lIns="0" rIns="0" tIns="0" bIns="0">
+            <a:spAutoFit/>
+          </a:bodyPr>
+          <a:lstStyle/>
+          <a:p>
+            <a:pPr algn="r"/>
+            <a:r>
+              <a:rPr sz="1100" b="1">
+                <a:solidFill>
+                  <a:srgbClr val="1967D2"/>
+                </a:solidFill>
+              </a:rPr>
+              <a:t>7 / 7</a:t>
+            </a:r>
+          </a:p>
+        </p:txBody>
+      </p:sp>
+      <p:sp>
+        <p:nvSpPr>
+          <p:cNvPr id="5" name="Rounded Rectangle 4"/>
+          <p:cNvSpPr/>
+          <p:nvPr/>
+        </p:nvSpPr>
+        <p:spPr>
+          <a:xfrm>
+            <a:off x="4093311" y="1234440"/>
+            <a:ext cx="4005072" cy="329184"/>
+          </a:xfrm>
+          <a:prstGeom prst="roundRect">
+            <a:avLst/>
+          </a:prstGeom>
+          <a:solidFill>
+            <a:srgbClr val="E8F0FE"/>
+          </a:solidFill>
+          <a:ln>
+            <a:noFill/>
+          </a:ln>
+        </p:spPr>
+        <p:style>
+          <a:lnRef idx="1">
+            <a:schemeClr val="accent1"/>
+          </a:lnRef>
+          <a:fillRef idx="3">
+            <a:schemeClr val="accent1"/>
+          </a:fillRef>
+          <a:effectRef idx="2">
+            <a:schemeClr val="accent1"/>
+          </a:effectRef>
+          <a:fontRef idx="minor">
+            <a:schemeClr val="lt1"/>
+          </a:fontRef>
+        </p:style>
+        <p:txBody>
+          <a:bodyPr rtlCol="0" anchor="ctr" tIns="0" bIns="0"/>
+          <a:lstStyle/>
+          <a:p>
+            <a:pPr algn="ctr"/>
+            <a:r>
+              <a:rPr sz="1000" b="1">
+                <a:solidFill>
+                  <a:srgbClr val="1967D2"/>
+                </a:solidFill>
+              </a:rPr>
+              <a:t>THE QUALITY FLYWHEEL IN ONE VIEW</a:t>
+            </a:r>
+          </a:p>
+        </p:txBody>
+      </p:sp>
+      <p:sp>
+        <p:nvSpPr>
+          <p:cNvPr id="6" name="TextBox 5"/>
+          <p:cNvSpPr txBox="1"/>
+          <p:nvPr/>
+        </p:nvSpPr>
+        <p:spPr>
+          <a:xfrm>
+            <a:off x="914400" y="1783080"/>
+            <a:ext cx="10362895" cy="1188720"/>
+          </a:xfrm>
+          <a:prstGeom prst="rect">
+            <a:avLst/>
+          </a:prstGeom>
+          <a:noFill/>
+        </p:spPr>
+        <p:txBody>
+          <a:bodyPr wrap="square" anchor="t" lIns="0" rIns="0" tIns="0" bIns="0">
+            <a:spAutoFit/>
+          </a:bodyPr>
+          <a:lstStyle/>
+          <a:p>
+            <a:pPr algn="ctr"/>
+            <a:r>
+              <a:rPr sz="3000">
+                <a:solidFill>
+                  <a:srgbClr val="202124"/>
+                </a:solidFill>
+                <a:latin typeface="Arial"/>
+              </a:rPr>
+              <a:t>From “seems to work” to </a:t>
+            </a:r>
+            <a:r>
+              <a:rPr sz="3000">
+                <a:solidFill>
+                  <a:srgbClr val="1A73E8"/>
+                </a:solidFill>
+                <a:latin typeface="Arial"/>
+              </a:rPr>
+              <a:t>measured &amp; monitored</a:t>
+            </a:r>
+          </a:p>
+        </p:txBody>
+      </p:sp>
+      <p:sp>
+        <p:nvSpPr>
+          <p:cNvPr id="7" name="TextBox 6"/>
+          <p:cNvSpPr txBox="1"/>
+          <p:nvPr/>
+        </p:nvSpPr>
+        <p:spPr>
+          <a:xfrm>
+            <a:off x="2148840" y="2468880"/>
+            <a:ext cx="7894015" cy="2377440"/>
+          </a:xfrm>
+          <a:prstGeom prst="rect">
+            <a:avLst/>
+          </a:prstGeom>
+          <a:noFill/>
+        </p:spPr>
+        <p:txBody>
+          <a:bodyPr wrap="square" anchor="t" lIns="0" rIns="0" tIns="0" bIns="0">
+            <a:spAutoFit/>
+          </a:bodyPr>
+          <a:lstStyle/>
+          <a:p>
+            <a:pPr>
+              <a:spcAft>
+                <a:spcPts val="900"/>
+              </a:spcAft>
+            </a:pPr>
+            <a:r>
+              <a:rPr sz="1100">
+                <a:solidFill>
+                  <a:srgbClr val="1A73E8"/>
+                </a:solidFill>
+              </a:rPr>
+              <a:t>●  </a:t>
+            </a:r>
+            <a:r>
+              <a:rPr sz="1300" b="1">
+                <a:solidFill>
+                  <a:srgbClr val="202124"/>
+                </a:solidFill>
+                <a:latin typeface="Arial"/>
+              </a:rPr>
+              <a:t>Design</a:t>
+            </a:r>
+            <a:r>
+              <a:rPr sz="1300" b="0">
+                <a:solidFill>
+                  <a:srgbClr val="3C4043"/>
+                </a:solidFill>
+                <a:latin typeface="Arial"/>
+              </a:rPr>
+              <a:t>: a reusable Metric Registry with predefined rubrics, custom LLM-as-judge, custom code, and reference-based Exact Match.</a:t>
+            </a:r>
+          </a:p>
+          <a:p>
+            <a:pPr>
+              <a:spcAft>
+                <a:spcPts val="900"/>
+              </a:spcAft>
+            </a:pPr>
+            <a:r>
+              <a:rPr sz="1100">
+                <a:solidFill>
+                  <a:srgbClr val="1A73E8"/>
+                </a:solidFill>
+              </a:rPr>
+              <a:t>●  </a:t>
+            </a:r>
+            <a:r>
+              <a:rPr sz="1300" b="1">
+                <a:solidFill>
+                  <a:srgbClr val="202124"/>
+                </a:solidFill>
+                <a:latin typeface="Arial"/>
+              </a:rPr>
+              <a:t>Execution</a:t>
+            </a:r>
+            <a:r>
+              <a:rPr sz="1300" b="0">
+                <a:solidFill>
+                  <a:srgbClr val="3C4043"/>
+                </a:solidFill>
+                <a:latin typeface="Arial"/>
+              </a:rPr>
+              <a:t>: generate traces three ways, batch in CI, simulated (with user and environment simulation), and offline over historical traces.</a:t>
+            </a:r>
+          </a:p>
+          <a:p>
+            <a:pPr>
+              <a:spcAft>
+                <a:spcPts val="900"/>
+              </a:spcAft>
+            </a:pPr>
+            <a:r>
+              <a:rPr sz="1100">
+                <a:solidFill>
+                  <a:srgbClr val="1A73E8"/>
+                </a:solidFill>
+              </a:rPr>
+              <a:t>●  </a:t>
+            </a:r>
+            <a:r>
+              <a:rPr sz="1300" b="1">
+                <a:solidFill>
+                  <a:srgbClr val="202124"/>
+                </a:solidFill>
+                <a:latin typeface="Arial"/>
+              </a:rPr>
+              <a:t>Scoring</a:t>
+            </a:r>
+            <a:r>
+              <a:rPr sz="1300" b="0">
+                <a:solidFill>
+                  <a:srgbClr val="3C4043"/>
+                </a:solidFill>
+                <a:latin typeface="Arial"/>
+              </a:rPr>
+              <a:t>: Online Monitors export every score as a Cloud Monitoring metric, visible in Metrics Explorer, dashboards, and drift alerts.</a:t>
+            </a:r>
+          </a:p>
+          <a:p>
+            <a:pPr>
+              <a:spcAft>
+                <a:spcPts val="900"/>
+              </a:spcAft>
+            </a:pPr>
+            <a:r>
+              <a:rPr sz="1100">
+                <a:solidFill>
+                  <a:srgbClr val="1A73E8"/>
+                </a:solidFill>
+              </a:rPr>
+              <a:t>●  </a:t>
+            </a:r>
+            <a:r>
+              <a:rPr sz="1300" b="1">
+                <a:solidFill>
+                  <a:srgbClr val="202124"/>
+                </a:solidFill>
+                <a:latin typeface="Arial"/>
+              </a:rPr>
+              <a:t>Refinement</a:t>
+            </a:r>
+            <a:r>
+              <a:rPr sz="1300" b="0">
+                <a:solidFill>
+                  <a:srgbClr val="3C4043"/>
+                </a:solidFill>
+                <a:latin typeface="Arial"/>
+              </a:rPr>
+              <a:t>: optimize the agent's instructions with GEPA, SimplePromptOptimizer, or agents-cli, then re-evaluate. Repeat.</a:t>
+            </a:r>
+          </a:p>
+        </p:txBody>
+      </p:sp>
+      <p:sp>
+        <p:nvSpPr>
+          <p:cNvPr id="8" name="TextBox 7"/>
+          <p:cNvSpPr txBox="1"/>
+          <p:nvPr/>
+        </p:nvSpPr>
+        <p:spPr>
+          <a:xfrm>
+            <a:off x="1371600" y="4873752"/>
+            <a:ext cx="9448495" cy="502920"/>
+          </a:xfrm>
+          <a:prstGeom prst="rect">
+            <a:avLst/>
+          </a:prstGeom>
+          <a:noFill/>
+        </p:spPr>
+        <p:txBody>
+          <a:bodyPr wrap="square" anchor="t" lIns="0" rIns="0" tIns="0" bIns="0">
+            <a:spAutoFit/>
+          </a:bodyPr>
+          <a:lstStyle/>
+          <a:p>
+            <a:pPr algn="ctr"/>
+            <a:r>
+              <a:rPr sz="1300" b="0">
+                <a:solidFill>
+                  <a:srgbClr val="5F6368"/>
+                </a:solidFill>
+                <a:latin typeface="Arial"/>
+              </a:rPr>
+              <a:t>Built clean: current Google clients from PyPI, </a:t>
+            </a:r>
+            <a:r>
+              <a:rPr sz="1300" b="1">
+                <a:solidFill>
+                  <a:srgbClr val="202124"/>
+                </a:solidFill>
+                <a:latin typeface="Arial"/>
+              </a:rPr>
+              <a:t>no monkey-patching</a:t>
+            </a:r>
+            <a:r>
+              <a:rPr sz="1300" b="0">
+                <a:solidFill>
+                  <a:srgbClr val="5F6368"/>
+                </a:solidFill>
+                <a:latin typeface="Arial"/>
+              </a:rPr>
+              <a:t>, and 161 passing tests.</a:t>
+            </a:r>
+          </a:p>
+        </p:txBody>
+      </p:sp>
+      <p:sp>
+        <p:nvSpPr>
+          <p:cNvPr id="9" name="Rounded Rectangle 8"/>
+          <p:cNvSpPr/>
+          <p:nvPr/>
+        </p:nvSpPr>
+        <p:spPr>
+          <a:xfrm>
+            <a:off x="1737360" y="5422392"/>
+            <a:ext cx="8716975" cy="457200"/>
+          </a:xfrm>
+          <a:prstGeom prst="roundRect">
+            <a:avLst/>
+          </a:prstGeom>
+          <a:solidFill>
+            <a:srgbClr val="202124"/>
+          </a:solidFill>
+          <a:ln>
+            <a:noFill/>
+          </a:ln>
+        </p:spPr>
+        <p:style>
+          <a:lnRef idx="1">
+            <a:schemeClr val="accent1"/>
+          </a:lnRef>
+          <a:fillRef idx="3">
+            <a:schemeClr val="accent1"/>
+          </a:fillRef>
+          <a:effectRef idx="2">
+            <a:schemeClr val="accent1"/>
+          </a:effectRef>
+          <a:fontRef idx="minor">
+            <a:schemeClr val="lt1"/>
+          </a:fontRef>
+        </p:style>
+        <p:txBody>
+          <a:bodyPr rtlCol="0" anchor="ctr" wrap="square" lIns="152400" tIns="25400" bIns="25400"/>
+          <a:lstStyle/>
+          <a:p>
+            <a:pPr algn="ctr"/>
+            <a:r>
+              <a:rPr sz="1200">
+                <a:solidFill>
+                  <a:srgbClr val="8AB4F8"/>
+                </a:solidFill>
+                <a:latin typeface="Consolas"/>
+              </a:rPr>
+              <a:t>$ </a:t>
+            </a:r>
+            <a:r>
+              <a:rPr sz="1200">
+                <a:solidFill>
+                  <a:srgbClr val="E8EAED"/>
+                </a:solidFill>
+                <a:latin typeface="Consolas"/>
+              </a:rPr>
+              <a:t>uv run python -m src.eval.demo.full_eval_demo --agent-id $AGENT_ENGINE_ID</a:t>
+            </a:r>
+          </a:p>
+        </p:txBody>
+      </p:sp>
+      <p:sp>
+        <p:nvSpPr>
+          <p:cNvPr id="10" name="TextBox 9"/>
+          <p:cNvSpPr txBox="1"/>
+          <p:nvPr/>
+        </p:nvSpPr>
+        <p:spPr>
+          <a:xfrm>
+            <a:off x="914400" y="6080759"/>
+            <a:ext cx="10362895" cy="365760"/>
+          </a:xfrm>
+          <a:prstGeom prst="rect">
+            <a:avLst/>
+          </a:prstGeom>
+          <a:noFill/>
+        </p:spPr>
+        <p:txBody>
+          <a:bodyPr wrap="square" anchor="t" lIns="0" rIns="0" tIns="0" bIns="0">
+            <a:spAutoFit/>
+          </a:bodyPr>
+          <a:lstStyle/>
+          <a:p>
+            <a:pPr algn="ctr"/>
+            <a:r>
+              <a:rPr sz="1200">
+                <a:solidFill>
+                  <a:srgbClr val="1A73E8"/>
+                </a:solidFill>
+                <a:hlinkClick r:id="rId2"/>
+              </a:rPr>
+              <a:t>Docs: Optimize / Evaluation ↗</a:t>
+            </a:r>
+            <a:r>
+              <a:rPr sz="1200">
+                <a:solidFill>
+                  <a:srgbClr val="5F6368"/>
+                </a:solidFill>
+              </a:rPr>
+              <a:t>      ·      </a:t>
+            </a:r>
+            <a:r>
+              <a:rPr sz="1200">
+                <a:solidFill>
+                  <a:srgbClr val="1A73E8"/>
+                </a:solidFill>
+                <a:hlinkClick r:id="rId3"/>
+              </a:rPr>
+              <a:t>Coverage matrix (§0) ↗</a:t>
+            </a:r>
+            <a:r>
+              <a:rPr sz="1200">
+                <a:solidFill>
+                  <a:srgbClr val="5F6368"/>
+                </a:solidFill>
+              </a:rPr>
+              <a:t>      ·      </a:t>
+            </a:r>
+            <a:r>
+              <a:rPr sz="1200">
+                <a:solidFill>
+                  <a:srgbClr val="1A73E8"/>
+                </a:solidFill>
+                <a:hlinkClick r:id="rId4"/>
+              </a:rPr>
+              <a:t>Demo walkthrough ↗</a:t>
+            </a:r>
+          </a:p>
+        </p:txBody>
+      </p:sp>
     </p:spTree>
   </p:cSld>
   <p:clrMapOvr>

</xml_diff>

<commit_message>
docs(eval): slide polish - drop monkey-patch mention, use live coordinator traces on slide 2
- remove the 'no monkey-patching' claim from the summary + title slides (HTML + PPTX)
- swap slide 2's screenshot to the coordinator's live Traces view (real sessions with
  model/tool calls + token usage) instead of the empty Evaluation console
</commit_message>
<xml_diff>
--- a/docs/eval_slides.pptx
+++ b/docs/eval_slides.pptx
@@ -4064,7 +4064,7 @@
       </p:sp>
       <p:pic>
         <p:nvPicPr>
-          <p:cNvPr id="11" name="Picture 10" descr="eval_console_evaluation.png"/>
+          <p:cNvPr id="11" name="Picture 10" descr="eval_console_agent_traces.png"/>
           <p:cNvPicPr>
             <a:picLocks noChangeAspect="1"/>
           </p:cNvPicPr>
@@ -6226,25 +6226,7 @@
                 </a:solidFill>
                 <a:latin typeface="Arial"/>
               </a:rPr>
-              <a:t>: current Google clients from PyPI, </a:t>
-            </a:r>
-            <a:r>
-              <a:rPr sz="1250" b="1">
-                <a:solidFill>
-                  <a:srgbClr val="202124"/>
-                </a:solidFill>
-                <a:latin typeface="Arial"/>
-              </a:rPr>
-              <a:t>no monkey-patching</a:t>
-            </a:r>
-            <a:r>
-              <a:rPr sz="1250" b="0">
-                <a:solidFill>
-                  <a:srgbClr val="3C4043"/>
-                </a:solidFill>
-                <a:latin typeface="Arial"/>
-              </a:rPr>
-              <a:t>, and 161 passing tests.</a:t>
+              <a:t>: current Google clients from PyPI, with 161 passing tests.</a:t>
             </a:r>
           </a:p>
         </p:txBody>
@@ -6793,25 +6775,7 @@
                 </a:solidFill>
                 <a:latin typeface="Arial"/>
               </a:rPr>
-              <a:t>Built clean: current Google clients from PyPI, </a:t>
-            </a:r>
-            <a:r>
-              <a:rPr sz="1300" b="1">
-                <a:solidFill>
-                  <a:srgbClr val="202124"/>
-                </a:solidFill>
-                <a:latin typeface="Arial"/>
-              </a:rPr>
-              <a:t>no monkey-patching</a:t>
-            </a:r>
-            <a:r>
-              <a:rPr sz="1300" b="0">
-                <a:solidFill>
-                  <a:srgbClr val="5F6368"/>
-                </a:solidFill>
-                <a:latin typeface="Arial"/>
-              </a:rPr>
-              <a:t>, and 161 passing tests.</a:t>
+              <a:t>Built clean: current Google clients from PyPI, with 161 passing tests.</a:t>
             </a:r>
           </a:p>
         </p:txBody>

</xml_diff>